<commit_message>
Summary + deck: SFT creates narration-free traces, steering only thins narration (new slide with native charts)
</commit_message>
<xml_diff>
--- a/META_DISCUSSION_SUMMARY.pptx
+++ b/META_DISCUSSION_SUMMARY.pptx
@@ -19,9 +19,10 @@
     <p:sldId id="267" r:id="rId13"/>
     <p:sldId id="268" r:id="rId14"/>
     <p:sldId id="269" r:id="rId15"/>
+    <p:sldId id="270" r:id="rId16"/>
   </p:sldIdLst>
   <p:notesMasterIdLst>
-    <p:notesMasterId r:id="rId16"/>
+    <p:notesMasterId r:id="rId17"/>
   </p:notesMasterIdLst>
   <p:sldSz cx="9144000" cy="5143500"/>
   <p:notesSz cx="5143500" cy="9144000"/>
@@ -118,6 +119,606 @@
     </a:lvl9pPr>
   </p:defaultTextStyle>
 </p:presentation>
+</file>
+
+<file path=ppt/charts/chart1.xml><?xml version="1.0" encoding="utf-8"?>
+<c:chartSpace xmlns:c="http://schemas.openxmlformats.org/drawingml/2006/chart" xmlns:a="http://schemas.openxmlformats.org/drawingml/2006/main" xmlns:r="http://schemas.openxmlformats.org/officeDocument/2006/relationships">
+  <c:date1904 val="0"/>
+  <c:roundedCorners val="1"/>
+  <c:chart>
+    <c:title>
+      <c:tx>
+        <c:rich>
+          <a:bodyPr/>
+          <a:lstStyle/>
+          <a:p>
+            <a:pPr>
+              <a:defRPr sz="1200" b="0" i="0" u="none" strike="noStrike">
+                <a:solidFill>
+                  <a:srgbClr val="0B0B0B"/>
+                </a:solidFill>
+                <a:latin typeface="Calibri"/>
+              </a:defRPr>
+            </a:pPr>
+            <a:r>
+              <a:rPr sz="1200" b="0" i="0" u="none" strike="noStrike">
+                <a:solidFill>
+                  <a:srgbClr val="0B0B0B"/>
+                </a:solidFill>
+                <a:latin typeface="Calibri"/>
+              </a:rPr>
+              <a:t>Traces with no narration at all, %</a:t>
+            </a:r>
+          </a:p>
+        </c:rich>
+      </c:tx>
+      <c:layout/>
+      <c:overlay val="0"/>
+    </c:title>
+    <c:autoTitleDeleted val="0"/>
+    <c:plotArea>
+      <c:layout/>
+      <c:barChart>
+        <c:barDir val="col"/>
+        <c:grouping val="clustered"/>
+        <c:varyColors val="0"/>
+        <c:ser>
+          <c:idx val="0"/>
+          <c:order val="0"/>
+          <c:tx>
+            <c:strRef>
+              <c:f>Sheet1!$B$1</c:f>
+              <c:strCache>
+                <c:ptCount val="1"/>
+                <c:pt idx="0">
+                  <c:v>narration-free</c:v>
+                </c:pt>
+              </c:strCache>
+            </c:strRef>
+          </c:tx>
+          <c:spPr>
+            <a:solidFill>
+              <a:srgbClr val="898781"/>
+            </a:solidFill>
+            <a:effectLst/>
+          </c:spPr>
+          <c:invertIfNegative val="0"/>
+          <c:dLbls>
+            <c:numFmt formatCode="0&quot;%&quot;" sourceLinked="0"/>
+            <c:txPr>
+              <a:bodyPr/>
+              <a:lstStyle/>
+              <a:p>
+                <a:pPr>
+                  <a:defRPr b="0" i="0" strike="noStrike" sz="1100" u="none">
+                    <a:solidFill>
+                      <a:srgbClr val="52514E"/>
+                    </a:solidFill>
+                    <a:latin typeface="Arial"/>
+                  </a:defRPr>
+                </a:pPr>
+              </a:p>
+            </c:txPr>
+            <c:showLegendKey val="0"/>
+            <c:showVal val="1"/>
+            <c:showCatName val="0"/>
+            <c:showSerName val="0"/>
+            <c:showPercent val="0"/>
+            <c:showBubbleSize val="0"/>
+            <c:showLeaderLines val="0"/>
+          </c:dLbls>
+          <c:dPt>
+            <c:idx val="0"/>
+            <c:invertIfNegative val="0"/>
+            <c:bubble3D val="0"/>
+            <c:spPr>
+              <a:solidFill>
+                <a:srgbClr val="898781"/>
+              </a:solidFill>
+              <a:effectLst/>
+            </c:spPr>
+          </c:dPt>
+          <c:dPt>
+            <c:idx val="1"/>
+            <c:invertIfNegative val="0"/>
+            <c:bubble3D val="0"/>
+            <c:spPr>
+              <a:solidFill>
+                <a:srgbClr val="2A78D6"/>
+              </a:solidFill>
+              <a:effectLst/>
+            </c:spPr>
+          </c:dPt>
+          <c:dPt>
+            <c:idx val="2"/>
+            <c:invertIfNegative val="0"/>
+            <c:bubble3D val="0"/>
+            <c:spPr>
+              <a:solidFill>
+                <a:srgbClr val="104281"/>
+              </a:solidFill>
+              <a:effectLst/>
+            </c:spPr>
+          </c:dPt>
+          <c:cat>
+            <c:multiLvlStrRef>
+              <c:f>Sheet1!$A$2:$A$4</c:f>
+              <c:multiLvlStrCache>
+                <c:ptCount val="3"/>
+                <c:lvl>
+                  <c:pt idx="0">
+                    <c:v>unsteered base</c:v>
+                  </c:pt>
+                  <c:pt idx="1">
+                    <c:v>steering, layer 16 −7</c:v>
+                  </c:pt>
+                  <c:pt idx="2">
+                    <c:v>SFT, step-60</c:v>
+                  </c:pt>
+                </c:lvl>
+              </c:multiLvlStrCache>
+            </c:multiLvlStrRef>
+          </c:cat>
+          <c:val>
+            <c:numRef>
+              <c:f>Sheet1!$B$2:$B$4</c:f>
+              <c:numCache>
+                <c:formatCode>General</c:formatCode>
+                <c:ptCount val="3"/>
+                <c:pt idx="0">
+                  <c:v>11</c:v>
+                </c:pt>
+                <c:pt idx="1">
+                  <c:v>17</c:v>
+                </c:pt>
+                <c:pt idx="2">
+                  <c:v>56</c:v>
+                </c:pt>
+              </c:numCache>
+            </c:numRef>
+          </c:val>
+        </c:ser>
+        <c:dLbls>
+          <c:numFmt formatCode="0&quot;%&quot;" sourceLinked="0"/>
+          <c:txPr>
+            <a:bodyPr/>
+            <a:lstStyle/>
+            <a:p>
+              <a:pPr>
+                <a:defRPr b="0" i="0" strike="noStrike" sz="1100" u="none">
+                  <a:solidFill>
+                    <a:srgbClr val="52514E"/>
+                  </a:solidFill>
+                  <a:latin typeface="Arial"/>
+                </a:defRPr>
+              </a:pPr>
+            </a:p>
+          </c:txPr>
+          <c:showLegendKey val="0"/>
+          <c:showVal val="1"/>
+          <c:showCatName val="0"/>
+          <c:showSerName val="0"/>
+          <c:showPercent val="0"/>
+          <c:showBubbleSize val="0"/>
+          <c:showLeaderLines val="0"/>
+        </c:dLbls>
+        <c:gapWidth val="60"/>
+        <c:overlap val="0"/>
+        <c:axId val="2094734554"/>
+        <c:axId val="2094734552"/>
+        <c:axId val="2094734556"/>
+      </c:barChart>
+      <c:catAx>
+        <c:axId val="2094734554"/>
+        <c:scaling>
+          <c:orientation val="minMax"/>
+        </c:scaling>
+        <c:delete val="0"/>
+        <c:axPos val="b"/>
+        <c:numFmt formatCode="General" sourceLinked="1"/>
+        <c:majorTickMark val="out"/>
+        <c:minorTickMark val="none"/>
+        <c:tickLblPos val="low"/>
+        <c:spPr>
+          <a:ln w="12700" cap="flat">
+            <a:noFill/>
+            <a:prstDash val="solid"/>
+            <a:round/>
+          </a:ln>
+        </c:spPr>
+        <c:txPr>
+          <a:bodyPr/>
+          <a:lstStyle/>
+          <a:p>
+            <a:pPr>
+              <a:defRPr sz="1100" b="0" i="0" u="none" strike="noStrike">
+                <a:solidFill>
+                  <a:srgbClr val="52514E"/>
+                </a:solidFill>
+                <a:latin typeface="Arial"/>
+              </a:defRPr>
+            </a:pPr>
+            <a:endParaRPr lang="en-US"/>
+          </a:p>
+        </c:txPr>
+        <c:crossAx val="2094734552"/>
+        <c:crosses val="autoZero"/>
+        <c:auto val="1"/>
+        <c:lblAlgn val="ctr"/>
+        <c:noMultiLvlLbl val="1"/>
+      </c:catAx>
+      <c:valAx>
+        <c:axId val="2094734552"/>
+        <c:scaling>
+          <c:orientation val="minMax"/>
+          <c:max val="70"/>
+          <c:min val="0"/>
+        </c:scaling>
+        <c:delete val="0"/>
+        <c:axPos val="l"/>
+        <c:majorGridlines>
+          <c:spPr>
+            <a:ln w="12700" cap="flat">
+              <a:solidFill>
+                <a:srgbClr val="E1E0D9"/>
+              </a:solidFill>
+              <a:prstDash val="solid"/>
+              <a:round/>
+            </a:ln>
+          </c:spPr>
+        </c:majorGridlines>
+        <c:numFmt formatCode="General" sourceLinked="0"/>
+        <c:majorTickMark val="out"/>
+        <c:minorTickMark val="none"/>
+        <c:tickLblPos val="nextTo"/>
+        <c:spPr>
+          <a:ln w="12700" cap="flat">
+            <a:noFill/>
+            <a:prstDash val="solid"/>
+            <a:round/>
+          </a:ln>
+        </c:spPr>
+        <c:txPr>
+          <a:bodyPr/>
+          <a:lstStyle/>
+          <a:p>
+            <a:pPr>
+              <a:defRPr sz="1000" b="0" i="0" u="none" strike="noStrike">
+                <a:solidFill>
+                  <a:srgbClr val="898781"/>
+                </a:solidFill>
+                <a:latin typeface="Arial"/>
+              </a:defRPr>
+            </a:pPr>
+            <a:endParaRPr lang="en-US"/>
+          </a:p>
+        </c:txPr>
+        <c:crossAx val="2094734554"/>
+        <c:crosses val="autoZero"/>
+        <c:crossBetween val="between"/>
+      </c:valAx>
+      <c:spPr>
+        <a:noFill/>
+        <a:ln>
+          <a:noFill/>
+        </a:ln>
+        <a:effectLst/>
+      </c:spPr>
+    </c:plotArea>
+    <c:plotVisOnly val="1"/>
+    <c:dispBlanksAs val="span"/>
+  </c:chart>
+  <c:spPr>
+    <a:noFill/>
+    <a:ln>
+      <a:noFill/>
+    </a:ln>
+    <a:effectLst/>
+  </c:spPr>
+  <c:externalData r:id="rId1">
+    <c:autoUpdate val="0"/>
+  </c:externalData>
+</c:chartSpace>
+</file>
+
+<file path=ppt/charts/chart2.xml><?xml version="1.0" encoding="utf-8"?>
+<c:chartSpace xmlns:c="http://schemas.openxmlformats.org/drawingml/2006/chart" xmlns:a="http://schemas.openxmlformats.org/drawingml/2006/main" xmlns:r="http://schemas.openxmlformats.org/officeDocument/2006/relationships">
+  <c:date1904 val="0"/>
+  <c:roundedCorners val="1"/>
+  <c:chart>
+    <c:title>
+      <c:tx>
+        <c:rich>
+          <a:bodyPr/>
+          <a:lstStyle/>
+          <a:p>
+            <a:pPr>
+              <a:defRPr sz="1200" b="0" i="0" u="none" strike="noStrike">
+                <a:solidFill>
+                  <a:srgbClr val="0B0B0B"/>
+                </a:solidFill>
+                <a:latin typeface="Calibri"/>
+              </a:defRPr>
+            </a:pPr>
+            <a:r>
+              <a:rPr sz="1200" b="0" i="0" u="none" strike="noStrike">
+                <a:solidFill>
+                  <a:srgbClr val="0B0B0B"/>
+                </a:solidFill>
+                <a:latin typeface="Calibri"/>
+              </a:rPr>
+              <a:t>Narration sentences per 1,000 words</a:t>
+            </a:r>
+          </a:p>
+        </c:rich>
+      </c:tx>
+      <c:layout/>
+      <c:overlay val="0"/>
+    </c:title>
+    <c:autoTitleDeleted val="0"/>
+    <c:plotArea>
+      <c:layout/>
+      <c:barChart>
+        <c:barDir val="col"/>
+        <c:grouping val="clustered"/>
+        <c:varyColors val="0"/>
+        <c:ser>
+          <c:idx val="0"/>
+          <c:order val="0"/>
+          <c:tx>
+            <c:strRef>
+              <c:f>Sheet1!$B$1</c:f>
+              <c:strCache>
+                <c:ptCount val="1"/>
+                <c:pt idx="0">
+                  <c:v>density</c:v>
+                </c:pt>
+              </c:strCache>
+            </c:strRef>
+          </c:tx>
+          <c:spPr>
+            <a:solidFill>
+              <a:srgbClr val="898781"/>
+            </a:solidFill>
+            <a:effectLst/>
+          </c:spPr>
+          <c:invertIfNegative val="0"/>
+          <c:dLbls>
+            <c:numFmt formatCode="0.0" sourceLinked="0"/>
+            <c:txPr>
+              <a:bodyPr/>
+              <a:lstStyle/>
+              <a:p>
+                <a:pPr>
+                  <a:defRPr b="0" i="0" strike="noStrike" sz="1100" u="none">
+                    <a:solidFill>
+                      <a:srgbClr val="52514E"/>
+                    </a:solidFill>
+                    <a:latin typeface="Arial"/>
+                  </a:defRPr>
+                </a:pPr>
+              </a:p>
+            </c:txPr>
+            <c:showLegendKey val="0"/>
+            <c:showVal val="1"/>
+            <c:showCatName val="0"/>
+            <c:showSerName val="0"/>
+            <c:showPercent val="0"/>
+            <c:showBubbleSize val="0"/>
+            <c:showLeaderLines val="0"/>
+          </c:dLbls>
+          <c:dPt>
+            <c:idx val="0"/>
+            <c:invertIfNegative val="0"/>
+            <c:bubble3D val="0"/>
+            <c:spPr>
+              <a:solidFill>
+                <a:srgbClr val="898781"/>
+              </a:solidFill>
+              <a:effectLst/>
+            </c:spPr>
+          </c:dPt>
+          <c:dPt>
+            <c:idx val="1"/>
+            <c:invertIfNegative val="0"/>
+            <c:bubble3D val="0"/>
+            <c:spPr>
+              <a:solidFill>
+                <a:srgbClr val="2A78D6"/>
+              </a:solidFill>
+              <a:effectLst/>
+            </c:spPr>
+          </c:dPt>
+          <c:dPt>
+            <c:idx val="2"/>
+            <c:invertIfNegative val="0"/>
+            <c:bubble3D val="0"/>
+            <c:spPr>
+              <a:solidFill>
+                <a:srgbClr val="104281"/>
+              </a:solidFill>
+              <a:effectLst/>
+            </c:spPr>
+          </c:dPt>
+          <c:cat>
+            <c:multiLvlStrRef>
+              <c:f>Sheet1!$A$2:$A$4</c:f>
+              <c:multiLvlStrCache>
+                <c:ptCount val="3"/>
+                <c:lvl>
+                  <c:pt idx="0">
+                    <c:v>unsteered base</c:v>
+                  </c:pt>
+                  <c:pt idx="1">
+                    <c:v>steering, layer 16 −7</c:v>
+                  </c:pt>
+                  <c:pt idx="2">
+                    <c:v>SFT, step-60</c:v>
+                  </c:pt>
+                </c:lvl>
+              </c:multiLvlStrCache>
+            </c:multiLvlStrRef>
+          </c:cat>
+          <c:val>
+            <c:numRef>
+              <c:f>Sheet1!$B$2:$B$4</c:f>
+              <c:numCache>
+                <c:formatCode>General</c:formatCode>
+                <c:ptCount val="3"/>
+                <c:pt idx="0">
+                  <c:v>6.1</c:v>
+                </c:pt>
+                <c:pt idx="1">
+                  <c:v>3.9</c:v>
+                </c:pt>
+                <c:pt idx="2">
+                  <c:v>1.8</c:v>
+                </c:pt>
+              </c:numCache>
+            </c:numRef>
+          </c:val>
+        </c:ser>
+        <c:dLbls>
+          <c:numFmt formatCode="0.0" sourceLinked="0"/>
+          <c:txPr>
+            <a:bodyPr/>
+            <a:lstStyle/>
+            <a:p>
+              <a:pPr>
+                <a:defRPr b="0" i="0" strike="noStrike" sz="1100" u="none">
+                  <a:solidFill>
+                    <a:srgbClr val="52514E"/>
+                  </a:solidFill>
+                  <a:latin typeface="Arial"/>
+                </a:defRPr>
+              </a:pPr>
+            </a:p>
+          </c:txPr>
+          <c:showLegendKey val="0"/>
+          <c:showVal val="1"/>
+          <c:showCatName val="0"/>
+          <c:showSerName val="0"/>
+          <c:showPercent val="0"/>
+          <c:showBubbleSize val="0"/>
+          <c:showLeaderLines val="0"/>
+        </c:dLbls>
+        <c:gapWidth val="60"/>
+        <c:overlap val="0"/>
+        <c:axId val="2094734554"/>
+        <c:axId val="2094734552"/>
+        <c:axId val="2094734556"/>
+      </c:barChart>
+      <c:catAx>
+        <c:axId val="2094734554"/>
+        <c:scaling>
+          <c:orientation val="minMax"/>
+        </c:scaling>
+        <c:delete val="0"/>
+        <c:axPos val="b"/>
+        <c:numFmt formatCode="General" sourceLinked="1"/>
+        <c:majorTickMark val="out"/>
+        <c:minorTickMark val="none"/>
+        <c:tickLblPos val="low"/>
+        <c:spPr>
+          <a:ln w="12700" cap="flat">
+            <a:noFill/>
+            <a:prstDash val="solid"/>
+            <a:round/>
+          </a:ln>
+        </c:spPr>
+        <c:txPr>
+          <a:bodyPr/>
+          <a:lstStyle/>
+          <a:p>
+            <a:pPr>
+              <a:defRPr sz="1100" b="0" i="0" u="none" strike="noStrike">
+                <a:solidFill>
+                  <a:srgbClr val="52514E"/>
+                </a:solidFill>
+                <a:latin typeface="Arial"/>
+              </a:defRPr>
+            </a:pPr>
+            <a:endParaRPr lang="en-US"/>
+          </a:p>
+        </c:txPr>
+        <c:crossAx val="2094734552"/>
+        <c:crosses val="autoZero"/>
+        <c:auto val="1"/>
+        <c:lblAlgn val="ctr"/>
+        <c:noMultiLvlLbl val="1"/>
+      </c:catAx>
+      <c:valAx>
+        <c:axId val="2094734552"/>
+        <c:scaling>
+          <c:orientation val="minMax"/>
+          <c:max val="8"/>
+          <c:min val="0"/>
+        </c:scaling>
+        <c:delete val="0"/>
+        <c:axPos val="l"/>
+        <c:majorGridlines>
+          <c:spPr>
+            <a:ln w="12700" cap="flat">
+              <a:solidFill>
+                <a:srgbClr val="E1E0D9"/>
+              </a:solidFill>
+              <a:prstDash val="solid"/>
+              <a:round/>
+            </a:ln>
+          </c:spPr>
+        </c:majorGridlines>
+        <c:numFmt formatCode="General" sourceLinked="0"/>
+        <c:majorTickMark val="out"/>
+        <c:minorTickMark val="none"/>
+        <c:tickLblPos val="nextTo"/>
+        <c:spPr>
+          <a:ln w="12700" cap="flat">
+            <a:noFill/>
+            <a:prstDash val="solid"/>
+            <a:round/>
+          </a:ln>
+        </c:spPr>
+        <c:txPr>
+          <a:bodyPr/>
+          <a:lstStyle/>
+          <a:p>
+            <a:pPr>
+              <a:defRPr sz="1000" b="0" i="0" u="none" strike="noStrike">
+                <a:solidFill>
+                  <a:srgbClr val="898781"/>
+                </a:solidFill>
+                <a:latin typeface="Arial"/>
+              </a:defRPr>
+            </a:pPr>
+            <a:endParaRPr lang="en-US"/>
+          </a:p>
+        </c:txPr>
+        <c:crossAx val="2094734554"/>
+        <c:crosses val="autoZero"/>
+        <c:crossBetween val="between"/>
+      </c:valAx>
+      <c:spPr>
+        <a:noFill/>
+        <a:ln>
+          <a:noFill/>
+        </a:ln>
+        <a:effectLst/>
+      </c:spPr>
+    </c:plotArea>
+    <c:plotVisOnly val="1"/>
+    <c:dispBlanksAs val="span"/>
+  </c:chart>
+  <c:spPr>
+    <a:noFill/>
+    <a:ln>
+      <a:noFill/>
+    </a:ln>
+    <a:effectLst/>
+  </c:spPr>
+  <c:externalData r:id="rId1">
+    <c:autoUpdate val="0"/>
+  </c:externalData>
+</c:chartSpace>
 </file>
 
 <file path=ppt/notesMasters/notesMaster1.xml><?xml version="1.0" encoding="utf-8"?>
@@ -979,6 +1580,94 @@
             <a:fld id="{F7021451-1387-4CA6-816F-3879F97B5CBC}" type="slidenum">
               <a:rPr lang="en-US"/>
               <a:t>14</a:t>
+            </a:fld>
+            <a:endParaRPr lang="en-US"/>
+          </a:p>
+        </p:txBody>
+      </p:sp>
+    </p:spTree>
+    <p:extLst>
+      <p:ext uri="{BB962C8B-B14F-4D97-AF65-F5344CB8AC3E}">
+        <p14:creationId xmlns:p14="http://schemas.microsoft.com/office/powerpoint/2010/main" val="1024086991"/>
+      </p:ext>
+    </p:extLst>
+  </p:cSld>
+  <p:clrMapOvr>
+    <a:masterClrMapping/>
+  </p:clrMapOvr>
+</p:notes>
+</file>
+
+<file path=ppt/notesSlides/notesSlide15.xml><?xml version="1.0" encoding="utf-8"?>
+<p:notes xmlns:a="http://schemas.openxmlformats.org/drawingml/2006/main" xmlns:r="http://schemas.openxmlformats.org/officeDocument/2006/relationships" xmlns:p="http://schemas.openxmlformats.org/presentationml/2006/main">
+  <p:cSld>
+    <p:spTree>
+      <p:nvGrpSpPr>
+        <p:cNvPr id="1" name=""/>
+        <p:cNvGrpSpPr/>
+        <p:nvPr/>
+      </p:nvGrpSpPr>
+      <p:grpSpPr>
+        <a:xfrm>
+          <a:off x="0" y="0"/>
+          <a:ext cx="0" cy="0"/>
+          <a:chOff x="0" y="0"/>
+          <a:chExt cx="0" cy="0"/>
+        </a:xfrm>
+      </p:grpSpPr>
+      <p:sp>
+        <p:nvSpPr>
+          <p:cNvPr id="2" name="Slide Image Placeholder 1"/>
+          <p:cNvSpPr>
+            <a:spLocks noGrp="1" noRot="1" noChangeAspect="1"/>
+          </p:cNvSpPr>
+          <p:nvPr>
+            <p:ph type="sldImg"/>
+          </p:nvPr>
+        </p:nvSpPr>
+        <p:spPr/>
+      </p:sp>
+      <p:sp>
+        <p:nvSpPr>
+          <p:cNvPr id="3" name="Notes Placeholder 2"/>
+          <p:cNvSpPr>
+            <a:spLocks noGrp="1"/>
+          </p:cNvSpPr>
+          <p:nvPr>
+            <p:ph type="body" idx="1"/>
+          </p:nvPr>
+        </p:nvSpPr>
+        <p:spPr/>
+        <p:txBody>
+          <a:bodyPr/>
+          <a:lstStyle/>
+          <a:p>
+            <a:r>
+              <a:rPr lang="en-US" dirty="0"/>
+              <a:t/>
+            </a:r>
+            <a:endParaRPr lang="en-US" dirty="0"/>
+          </a:p>
+        </p:txBody>
+      </p:sp>
+      <p:sp>
+        <p:nvSpPr>
+          <p:cNvPr id="4" name="Slide Number Placeholder 3"/>
+          <p:cNvSpPr>
+            <a:spLocks noGrp="1"/>
+          </p:cNvSpPr>
+          <p:nvPr>
+            <p:ph type="sldNum" sz="quarter" idx="10"/>
+          </p:nvPr>
+        </p:nvSpPr>
+        <p:spPr/>
+        <p:txBody>
+          <a:bodyPr/>
+          <a:lstStyle/>
+          <a:p>
+            <a:fld id="{F7021451-1387-4CA6-816F-3879F97B5CBC}" type="slidenum">
+              <a:rPr lang="en-US"/>
+              <a:t>15</a:t>
             </a:fld>
             <a:endParaRPr lang="en-US"/>
           </a:p>
@@ -2688,7 +3377,7 @@
                 <a:ea typeface="Calibri" pitchFamily="34" charset="-122"/>
                 <a:cs typeface="Calibri" pitchFamily="34" charset="-120"/>
               </a:rPr>
-              <a:t>5 · If narration were gone, would compliance rise?  No</a:t>
+              <a:t>SFT creates narration-free traces; steering only thins narration</a:t>
             </a:r>
             <a:endParaRPr lang="en-US" sz="2200" dirty="0"/>
           </a:p>
@@ -2727,255 +3416,54 @@
                 <a:ea typeface="Calibri" pitchFamily="34" charset="-122"/>
                 <a:cs typeface="Calibri" pitchFamily="34" charset="-120"/>
               </a:rPr>
-              <a:t>Delete every LLM-labelled narration sentence from every stored trace and re-grade: the ceiling for any narration-only method</a:t>
+              <a:t>Full-trace LLM lister · CoTControl · SFT = step-60 (all modes) · steering = layer 16, −7 (uppercase + word suppression, n 24)</a:t>
             </a:r>
             <a:endParaRPr lang="en-US" sz="1200" dirty="0"/>
           </a:p>
         </p:txBody>
       </p:sp>
-      <p:pic>
-        <p:nvPicPr>
-          <p:cNvPr id="4" name="Image 0" descr="/home/ola/dev/cot-control-ft/figures/llm_strip_cotcontrol.png">    </p:cNvPr>
-          <p:cNvPicPr>
-            <a:picLocks noChangeAspect="1"/>
-          </p:cNvPicPr>
-          <p:nvPr/>
-        </p:nvPicPr>
-        <p:blipFill>
-          <a:blip r:embed="rId1"/>
-          <a:srcRect l="0" r="0" t="0" b="0"/>
-          <a:stretch/>
-        </p:blipFill>
-        <p:spPr>
-          <a:xfrm>
-            <a:off x="365760" y="1280160"/>
-            <a:ext cx="5120640" cy="3200400"/>
-          </a:xfrm>
-          <a:prstGeom prst="rect">
-            <a:avLst/>
-          </a:prstGeom>
-        </p:spPr>
-      </p:pic>
-      <p:sp>
-        <p:nvSpPr>
-          <p:cNvPr id="5" name="Shape 2"/>
-          <p:cNvSpPr/>
-          <p:nvPr/>
-        </p:nvSpPr>
-        <p:spPr>
-          <a:xfrm>
-            <a:off x="5760720" y="1234440"/>
-            <a:ext cx="3017520" cy="960120"/>
-          </a:xfrm>
-          <a:prstGeom prst="roundRect">
-            <a:avLst>
-              <a:gd name="adj" fmla="val 7619"/>
-            </a:avLst>
-          </a:prstGeom>
-          <a:solidFill>
-            <a:srgbClr val="EEF4FC"/>
-          </a:solidFill>
-          <a:ln w="12700">
-            <a:solidFill>
-              <a:srgbClr val="EEF4FC"/>
-            </a:solidFill>
-            <a:prstDash val="solid"/>
-          </a:ln>
-        </p:spPr>
-      </p:sp>
-      <p:sp>
-        <p:nvSpPr>
-          <p:cNvPr id="6" name="Text 3"/>
+      <p:graphicFrame>
+        <p:nvGraphicFramePr>
+          <p:cNvPr id="4" name="Chart 0" descr=""/>
+          <p:cNvGraphicFramePr/>
+          <p:nvPr/>
+        </p:nvGraphicFramePr>
+        <p:xfrm>
+          <a:off x="457200" y="1280160"/>
+          <a:ext cx="4023360" cy="2834640"/>
+        </p:xfrm>
+        <a:graphic xmlns:a="http://schemas.openxmlformats.org/drawingml/2006/main">
+          <a:graphicData uri="http://schemas.openxmlformats.org/drawingml/2006/chart">
+            <c:chart xmlns:c="http://schemas.openxmlformats.org/drawingml/2006/chart" r:id="rId1"/>
+          </a:graphicData>
+        </a:graphic>
+      </p:graphicFrame>
+      <p:graphicFrame>
+        <p:nvGraphicFramePr>
+          <p:cNvPr id="5" name="Chart 1" descr=""/>
+          <p:cNvGraphicFramePr/>
+          <p:nvPr/>
+        </p:nvGraphicFramePr>
+        <p:xfrm>
+          <a:off x="4663440" y="1280160"/>
+          <a:ext cx="4023360" cy="2834640"/>
+        </p:xfrm>
+        <a:graphic xmlns:a="http://schemas.openxmlformats.org/drawingml/2006/main">
+          <a:graphicData uri="http://schemas.openxmlformats.org/drawingml/2006/chart">
+            <c:chart xmlns:c="http://schemas.openxmlformats.org/drawingml/2006/chart" r:id="rId2"/>
+          </a:graphicData>
+        </a:graphic>
+      </p:graphicFrame>
+      <p:sp>
+        <p:nvSpPr>
+          <p:cNvPr id="6" name="Text 2"/>
           <p:cNvSpPr txBox="1"/>
           <p:nvPr/>
         </p:nvSpPr>
         <p:spPr>
           <a:xfrm>
-            <a:off x="5897880" y="1307592"/>
-            <a:ext cx="2743200" cy="457200"/>
-          </a:xfrm>
-          <a:prstGeom prst="rect">
-            <a:avLst/>
-          </a:prstGeom>
-          <a:noFill/>
-          <a:ln/>
-        </p:spPr>
-        <p:txBody>
-          <a:bodyPr wrap="square" lIns="0" tIns="0" rIns="0" bIns="0" rtlCol="0" anchor="ctr"/>
-          <a:lstStyle/>
-          <a:p>
-            <a:pPr indent="0" marL="0">
-              <a:buNone/>
-            </a:pPr>
-            <a:r>
-              <a:rPr lang="en-US" sz="2600" b="1" dirty="0">
-                <a:solidFill>
-                  <a:srgbClr val="104281"/>
-                </a:solidFill>
-                <a:latin typeface="Calibri" pitchFamily="34" charset="0"/>
-                <a:ea typeface="Calibri" pitchFamily="34" charset="-122"/>
-                <a:cs typeface="Calibri" pitchFamily="34" charset="-120"/>
-              </a:rPr>
-              <a:t>0 / 2,588</a:t>
-            </a:r>
-            <a:endParaRPr lang="en-US" sz="2600" dirty="0"/>
-          </a:p>
-        </p:txBody>
-      </p:sp>
-      <p:sp>
-        <p:nvSpPr>
-          <p:cNvPr id="7" name="Text 4"/>
-          <p:cNvSpPr txBox="1"/>
-          <p:nvPr/>
-        </p:nvSpPr>
-        <p:spPr>
-          <a:xfrm>
-            <a:off x="5897880" y="1737360"/>
-            <a:ext cx="2743200" cy="411480"/>
-          </a:xfrm>
-          <a:prstGeom prst="rect">
-            <a:avLst/>
-          </a:prstGeom>
-          <a:noFill/>
-          <a:ln/>
-        </p:spPr>
-        <p:txBody>
-          <a:bodyPr wrap="square" lIns="0" tIns="0" rIns="0" bIns="0" rtlCol="0" anchor="t"/>
-          <a:lstStyle/>
-          <a:p>
-            <a:pPr indent="0" marL="0">
-              <a:buNone/>
-            </a:pPr>
-            <a:r>
-              <a:rPr lang="en-US" sz="1050" dirty="0">
-                <a:solidFill>
-                  <a:srgbClr val="52514E"/>
-                </a:solidFill>
-                <a:latin typeface="Calibri" pitchFamily="34" charset="0"/>
-                <a:ea typeface="Calibri" pitchFamily="34" charset="-122"/>
-                <a:cs typeface="Calibri" pitchFamily="34" charset="-120"/>
-              </a:rPr>
-              <a:t>base CoTControl traces flip fail → pass after deleting all narration</a:t>
-            </a:r>
-            <a:endParaRPr lang="en-US" sz="1050" dirty="0"/>
-          </a:p>
-        </p:txBody>
-      </p:sp>
-      <p:sp>
-        <p:nvSpPr>
-          <p:cNvPr id="8" name="Shape 5"/>
-          <p:cNvSpPr/>
-          <p:nvPr/>
-        </p:nvSpPr>
-        <p:spPr>
-          <a:xfrm>
-            <a:off x="5760720" y="2286000"/>
-            <a:ext cx="3017520" cy="960120"/>
-          </a:xfrm>
-          <a:prstGeom prst="roundRect">
-            <a:avLst>
-              <a:gd name="adj" fmla="val 7619"/>
-            </a:avLst>
-          </a:prstGeom>
-          <a:solidFill>
-            <a:srgbClr val="EEF4FC"/>
-          </a:solidFill>
-          <a:ln w="12700">
-            <a:solidFill>
-              <a:srgbClr val="EEF4FC"/>
-            </a:solidFill>
-            <a:prstDash val="solid"/>
-          </a:ln>
-        </p:spPr>
-      </p:sp>
-      <p:sp>
-        <p:nvSpPr>
-          <p:cNvPr id="9" name="Text 6"/>
-          <p:cNvSpPr txBox="1"/>
-          <p:nvPr/>
-        </p:nvSpPr>
-        <p:spPr>
-          <a:xfrm>
-            <a:off x="5897880" y="2359152"/>
-            <a:ext cx="2743200" cy="457200"/>
-          </a:xfrm>
-          <a:prstGeom prst="rect">
-            <a:avLst/>
-          </a:prstGeom>
-          <a:noFill/>
-          <a:ln/>
-        </p:spPr>
-        <p:txBody>
-          <a:bodyPr wrap="square" lIns="0" tIns="0" rIns="0" bIns="0" rtlCol="0" anchor="ctr"/>
-          <a:lstStyle/>
-          <a:p>
-            <a:pPr indent="0" marL="0">
-              <a:buNone/>
-            </a:pPr>
-            <a:r>
-              <a:rPr lang="en-US" sz="2600" b="1" dirty="0">
-                <a:solidFill>
-                  <a:srgbClr val="104281"/>
-                </a:solidFill>
-                <a:latin typeface="Calibri" pitchFamily="34" charset="0"/>
-                <a:ea typeface="Calibri" pitchFamily="34" charset="-122"/>
-                <a:cs typeface="Calibri" pitchFamily="34" charset="-120"/>
-              </a:rPr>
-              <a:t>0 / 496</a:t>
-            </a:r>
-            <a:endParaRPr lang="en-US" sz="2600" dirty="0"/>
-          </a:p>
-        </p:txBody>
-      </p:sp>
-      <p:sp>
-        <p:nvSpPr>
-          <p:cNvPr id="10" name="Text 7"/>
-          <p:cNvSpPr txBox="1"/>
-          <p:nvPr/>
-        </p:nvSpPr>
-        <p:spPr>
-          <a:xfrm>
-            <a:off x="5897880" y="2788920"/>
-            <a:ext cx="2743200" cy="411480"/>
-          </a:xfrm>
-          <a:prstGeom prst="rect">
-            <a:avLst/>
-          </a:prstGeom>
-          <a:noFill/>
-          <a:ln/>
-        </p:spPr>
-        <p:txBody>
-          <a:bodyPr wrap="square" lIns="0" tIns="0" rIns="0" bIns="0" rtlCol="0" anchor="t"/>
-          <a:lstStyle/>
-          <a:p>
-            <a:pPr indent="0" marL="0">
-              <a:buNone/>
-            </a:pPr>
-            <a:r>
-              <a:rPr lang="en-US" sz="1050" dirty="0">
-                <a:solidFill>
-                  <a:srgbClr val="52514E"/>
-                </a:solidFill>
-                <a:latin typeface="Calibri" pitchFamily="34" charset="0"/>
-                <a:ea typeface="Calibri" pitchFamily="34" charset="-122"/>
-                <a:cs typeface="Calibri" pitchFamily="34" charset="-120"/>
-              </a:rPr>
-              <a:t>at step-60; ReasonIF 2 / 262 and 0 / 105</a:t>
-            </a:r>
-            <a:endParaRPr lang="en-US" sz="1050" dirty="0"/>
-          </a:p>
-        </p:txBody>
-      </p:sp>
-      <p:sp>
-        <p:nvSpPr>
-          <p:cNvPr id="11" name="Text 8"/>
-          <p:cNvSpPr txBox="1"/>
-          <p:nvPr/>
-        </p:nvSpPr>
-        <p:spPr>
-          <a:xfrm>
-            <a:off x="5760720" y="3337560"/>
-            <a:ext cx="3017520" cy="1280160"/>
+            <a:off x="457200" y="4206240"/>
+            <a:ext cx="8229600" cy="548640"/>
           </a:xfrm>
           <a:prstGeom prst="rect">
             <a:avLst/>
@@ -3003,7 +3491,7 @@
                 <a:ea typeface="Calibri" pitchFamily="34" charset="-122"/>
                 <a:cs typeface="Calibri" pitchFamily="34" charset="-120"/>
               </a:rPr>
-              <a:t>Narration is 5–8 % of the text; the body breaks the same rule in 90–99 % of its own sentences</a:t>
+              <a:t>Steering lowers the propensity everywhere but leaves narration in nearly every trace (0 of 12 word-suppression traces became narration-free; median still 11 sentences)</a:t>
             </a:r>
             <a:endParaRPr lang="en-US" sz="1100" dirty="0"/>
           </a:p>
@@ -3024,9 +3512,48 @@
                 <a:ea typeface="Calibri" pitchFamily="34" charset="-122"/>
                 <a:cs typeface="Calibri" pitchFamily="34" charset="-120"/>
               </a:rPr>
-              <a:t>Largest continuous gain in any condition: +0.05</a:t>
+              <a:t>The coefficient that does remove it (−14) breaks generation. SFT removes it outright from more than half the traces while keeping them intact</a:t>
             </a:r>
             <a:endParaRPr lang="en-US" sz="1100" dirty="0"/>
+          </a:p>
+        </p:txBody>
+      </p:sp>
+      <p:sp>
+        <p:nvSpPr>
+          <p:cNvPr id="7" name="Text 3"/>
+          <p:cNvSpPr txBox="1"/>
+          <p:nvPr/>
+        </p:nvSpPr>
+        <p:spPr>
+          <a:xfrm>
+            <a:off x="457200" y="4709160"/>
+            <a:ext cx="8229600" cy="365760"/>
+          </a:xfrm>
+          <a:prstGeom prst="rect">
+            <a:avLst/>
+          </a:prstGeom>
+          <a:noFill/>
+          <a:ln/>
+        </p:spPr>
+        <p:txBody>
+          <a:bodyPr wrap="square" lIns="0" tIns="0" rIns="0" bIns="0" rtlCol="0" anchor="t"/>
+          <a:lstStyle/>
+          <a:p>
+            <a:pPr indent="0" marL="0">
+              <a:buNone/>
+            </a:pPr>
+            <a:r>
+              <a:rPr lang="en-US" sz="850" dirty="0">
+                <a:solidFill>
+                  <a:srgbClr val="898781"/>
+                </a:solidFill>
+                <a:latin typeface="Calibri" pitchFamily="34" charset="0"/>
+                <a:ea typeface="Calibri" pitchFamily="34" charset="-122"/>
+                <a:cs typeface="Calibri" pitchFamily="34" charset="-120"/>
+              </a:rPr>
+              <a:t>Steering densities use the two-mode subset it was run on (unsteered 5.3 → 3.9 on that subset); the 6.1 baseline is the full base set</a:t>
+            </a:r>
+            <a:endParaRPr lang="en-US" sz="850" dirty="0"/>
           </a:p>
         </p:txBody>
       </p:sp>
@@ -3041,6 +3568,408 @@
 <file path=ppt/slides/slide13.xml><?xml version="1.0" encoding="utf-8"?>
 <p:sld xmlns:a="http://schemas.openxmlformats.org/drawingml/2006/main" xmlns:r="http://schemas.openxmlformats.org/officeDocument/2006/relationships" xmlns:p="http://schemas.openxmlformats.org/presentationml/2006/main">
   <p:cSld name="Slide 13">
+    <p:spTree>
+      <p:nvGrpSpPr>
+        <p:cNvPr id="1" name=""/>
+        <p:cNvGrpSpPr/>
+        <p:nvPr/>
+      </p:nvGrpSpPr>
+      <p:grpSpPr>
+        <a:xfrm>
+          <a:off x="0" y="0"/>
+          <a:ext cx="0" cy="0"/>
+          <a:chOff x="0" y="0"/>
+          <a:chExt cx="0" cy="0"/>
+        </a:xfrm>
+      </p:grpSpPr>
+      <p:sp>
+        <p:nvSpPr>
+          <p:cNvPr id="2" name="Text 0"/>
+          <p:cNvSpPr txBox="1"/>
+          <p:nvPr/>
+        </p:nvSpPr>
+        <p:spPr>
+          <a:xfrm>
+            <a:off x="457200" y="256032"/>
+            <a:ext cx="8229600" cy="502920"/>
+          </a:xfrm>
+          <a:prstGeom prst="rect">
+            <a:avLst/>
+          </a:prstGeom>
+          <a:noFill/>
+          <a:ln/>
+        </p:spPr>
+        <p:txBody>
+          <a:bodyPr wrap="square" lIns="0" tIns="0" rIns="0" bIns="0" rtlCol="0" anchor="ctr">
+            <a:normAutofit/>
+          </a:bodyPr>
+          <a:lstStyle/>
+          <a:p>
+            <a:pPr indent="0" marL="0">
+              <a:buNone/>
+            </a:pPr>
+            <a:r>
+              <a:rPr lang="en-US" sz="2200" b="1" dirty="0">
+                <a:solidFill>
+                  <a:srgbClr val="0B0B0B"/>
+                </a:solidFill>
+                <a:latin typeface="Calibri" pitchFamily="34" charset="0"/>
+                <a:ea typeface="Calibri" pitchFamily="34" charset="-122"/>
+                <a:cs typeface="Calibri" pitchFamily="34" charset="-120"/>
+              </a:rPr>
+              <a:t>5 · If narration were gone, would compliance rise?  No</a:t>
+            </a:r>
+            <a:endParaRPr lang="en-US" sz="2200" dirty="0"/>
+          </a:p>
+        </p:txBody>
+      </p:sp>
+      <p:sp>
+        <p:nvSpPr>
+          <p:cNvPr id="3" name="Text 1"/>
+          <p:cNvSpPr txBox="1"/>
+          <p:nvPr/>
+        </p:nvSpPr>
+        <p:spPr>
+          <a:xfrm>
+            <a:off x="457200" y="749808"/>
+            <a:ext cx="8229600" cy="411480"/>
+          </a:xfrm>
+          <a:prstGeom prst="rect">
+            <a:avLst/>
+          </a:prstGeom>
+          <a:noFill/>
+          <a:ln/>
+        </p:spPr>
+        <p:txBody>
+          <a:bodyPr wrap="square" lIns="0" tIns="0" rIns="0" bIns="0" rtlCol="0" anchor="t"/>
+          <a:lstStyle/>
+          <a:p>
+            <a:pPr indent="0" marL="0">
+              <a:buNone/>
+            </a:pPr>
+            <a:r>
+              <a:rPr lang="en-US" sz="1200" dirty="0">
+                <a:solidFill>
+                  <a:srgbClr val="52514E"/>
+                </a:solidFill>
+                <a:latin typeface="Calibri" pitchFamily="34" charset="0"/>
+                <a:ea typeface="Calibri" pitchFamily="34" charset="-122"/>
+                <a:cs typeface="Calibri" pitchFamily="34" charset="-120"/>
+              </a:rPr>
+              <a:t>Delete every LLM-labelled narration sentence from every stored trace and re-grade: the ceiling for any narration-only method</a:t>
+            </a:r>
+            <a:endParaRPr lang="en-US" sz="1200" dirty="0"/>
+          </a:p>
+        </p:txBody>
+      </p:sp>
+      <p:pic>
+        <p:nvPicPr>
+          <p:cNvPr id="4" name="Image 0" descr="/home/ola/dev/cot-control-ft/figures/llm_strip_cotcontrol.png">    </p:cNvPr>
+          <p:cNvPicPr>
+            <a:picLocks noChangeAspect="1"/>
+          </p:cNvPicPr>
+          <p:nvPr/>
+        </p:nvPicPr>
+        <p:blipFill>
+          <a:blip r:embed="rId1"/>
+          <a:srcRect l="0" r="0" t="0" b="0"/>
+          <a:stretch/>
+        </p:blipFill>
+        <p:spPr>
+          <a:xfrm>
+            <a:off x="365760" y="1280160"/>
+            <a:ext cx="5120640" cy="3200400"/>
+          </a:xfrm>
+          <a:prstGeom prst="rect">
+            <a:avLst/>
+          </a:prstGeom>
+        </p:spPr>
+      </p:pic>
+      <p:sp>
+        <p:nvSpPr>
+          <p:cNvPr id="5" name="Shape 2"/>
+          <p:cNvSpPr/>
+          <p:nvPr/>
+        </p:nvSpPr>
+        <p:spPr>
+          <a:xfrm>
+            <a:off x="5760720" y="1234440"/>
+            <a:ext cx="3017520" cy="960120"/>
+          </a:xfrm>
+          <a:prstGeom prst="roundRect">
+            <a:avLst>
+              <a:gd name="adj" fmla="val 7619"/>
+            </a:avLst>
+          </a:prstGeom>
+          <a:solidFill>
+            <a:srgbClr val="EEF4FC"/>
+          </a:solidFill>
+          <a:ln w="12700">
+            <a:solidFill>
+              <a:srgbClr val="EEF4FC"/>
+            </a:solidFill>
+            <a:prstDash val="solid"/>
+          </a:ln>
+        </p:spPr>
+      </p:sp>
+      <p:sp>
+        <p:nvSpPr>
+          <p:cNvPr id="6" name="Text 3"/>
+          <p:cNvSpPr txBox="1"/>
+          <p:nvPr/>
+        </p:nvSpPr>
+        <p:spPr>
+          <a:xfrm>
+            <a:off x="5897880" y="1307592"/>
+            <a:ext cx="2743200" cy="457200"/>
+          </a:xfrm>
+          <a:prstGeom prst="rect">
+            <a:avLst/>
+          </a:prstGeom>
+          <a:noFill/>
+          <a:ln/>
+        </p:spPr>
+        <p:txBody>
+          <a:bodyPr wrap="square" lIns="0" tIns="0" rIns="0" bIns="0" rtlCol="0" anchor="ctr"/>
+          <a:lstStyle/>
+          <a:p>
+            <a:pPr indent="0" marL="0">
+              <a:buNone/>
+            </a:pPr>
+            <a:r>
+              <a:rPr lang="en-US" sz="2600" b="1" dirty="0">
+                <a:solidFill>
+                  <a:srgbClr val="104281"/>
+                </a:solidFill>
+                <a:latin typeface="Calibri" pitchFamily="34" charset="0"/>
+                <a:ea typeface="Calibri" pitchFamily="34" charset="-122"/>
+                <a:cs typeface="Calibri" pitchFamily="34" charset="-120"/>
+              </a:rPr>
+              <a:t>0 / 2,588</a:t>
+            </a:r>
+            <a:endParaRPr lang="en-US" sz="2600" dirty="0"/>
+          </a:p>
+        </p:txBody>
+      </p:sp>
+      <p:sp>
+        <p:nvSpPr>
+          <p:cNvPr id="7" name="Text 4"/>
+          <p:cNvSpPr txBox="1"/>
+          <p:nvPr/>
+        </p:nvSpPr>
+        <p:spPr>
+          <a:xfrm>
+            <a:off x="5897880" y="1737360"/>
+            <a:ext cx="2743200" cy="411480"/>
+          </a:xfrm>
+          <a:prstGeom prst="rect">
+            <a:avLst/>
+          </a:prstGeom>
+          <a:noFill/>
+          <a:ln/>
+        </p:spPr>
+        <p:txBody>
+          <a:bodyPr wrap="square" lIns="0" tIns="0" rIns="0" bIns="0" rtlCol="0" anchor="t"/>
+          <a:lstStyle/>
+          <a:p>
+            <a:pPr indent="0" marL="0">
+              <a:buNone/>
+            </a:pPr>
+            <a:r>
+              <a:rPr lang="en-US" sz="1050" dirty="0">
+                <a:solidFill>
+                  <a:srgbClr val="52514E"/>
+                </a:solidFill>
+                <a:latin typeface="Calibri" pitchFamily="34" charset="0"/>
+                <a:ea typeface="Calibri" pitchFamily="34" charset="-122"/>
+                <a:cs typeface="Calibri" pitchFamily="34" charset="-120"/>
+              </a:rPr>
+              <a:t>base CoTControl traces flip fail → pass after deleting all narration</a:t>
+            </a:r>
+            <a:endParaRPr lang="en-US" sz="1050" dirty="0"/>
+          </a:p>
+        </p:txBody>
+      </p:sp>
+      <p:sp>
+        <p:nvSpPr>
+          <p:cNvPr id="8" name="Shape 5"/>
+          <p:cNvSpPr/>
+          <p:nvPr/>
+        </p:nvSpPr>
+        <p:spPr>
+          <a:xfrm>
+            <a:off x="5760720" y="2286000"/>
+            <a:ext cx="3017520" cy="960120"/>
+          </a:xfrm>
+          <a:prstGeom prst="roundRect">
+            <a:avLst>
+              <a:gd name="adj" fmla="val 7619"/>
+            </a:avLst>
+          </a:prstGeom>
+          <a:solidFill>
+            <a:srgbClr val="EEF4FC"/>
+          </a:solidFill>
+          <a:ln w="12700">
+            <a:solidFill>
+              <a:srgbClr val="EEF4FC"/>
+            </a:solidFill>
+            <a:prstDash val="solid"/>
+          </a:ln>
+        </p:spPr>
+      </p:sp>
+      <p:sp>
+        <p:nvSpPr>
+          <p:cNvPr id="9" name="Text 6"/>
+          <p:cNvSpPr txBox="1"/>
+          <p:nvPr/>
+        </p:nvSpPr>
+        <p:spPr>
+          <a:xfrm>
+            <a:off x="5897880" y="2359152"/>
+            <a:ext cx="2743200" cy="457200"/>
+          </a:xfrm>
+          <a:prstGeom prst="rect">
+            <a:avLst/>
+          </a:prstGeom>
+          <a:noFill/>
+          <a:ln/>
+        </p:spPr>
+        <p:txBody>
+          <a:bodyPr wrap="square" lIns="0" tIns="0" rIns="0" bIns="0" rtlCol="0" anchor="ctr"/>
+          <a:lstStyle/>
+          <a:p>
+            <a:pPr indent="0" marL="0">
+              <a:buNone/>
+            </a:pPr>
+            <a:r>
+              <a:rPr lang="en-US" sz="2600" b="1" dirty="0">
+                <a:solidFill>
+                  <a:srgbClr val="104281"/>
+                </a:solidFill>
+                <a:latin typeface="Calibri" pitchFamily="34" charset="0"/>
+                <a:ea typeface="Calibri" pitchFamily="34" charset="-122"/>
+                <a:cs typeface="Calibri" pitchFamily="34" charset="-120"/>
+              </a:rPr>
+              <a:t>0 / 496</a:t>
+            </a:r>
+            <a:endParaRPr lang="en-US" sz="2600" dirty="0"/>
+          </a:p>
+        </p:txBody>
+      </p:sp>
+      <p:sp>
+        <p:nvSpPr>
+          <p:cNvPr id="10" name="Text 7"/>
+          <p:cNvSpPr txBox="1"/>
+          <p:nvPr/>
+        </p:nvSpPr>
+        <p:spPr>
+          <a:xfrm>
+            <a:off x="5897880" y="2788920"/>
+            <a:ext cx="2743200" cy="411480"/>
+          </a:xfrm>
+          <a:prstGeom prst="rect">
+            <a:avLst/>
+          </a:prstGeom>
+          <a:noFill/>
+          <a:ln/>
+        </p:spPr>
+        <p:txBody>
+          <a:bodyPr wrap="square" lIns="0" tIns="0" rIns="0" bIns="0" rtlCol="0" anchor="t"/>
+          <a:lstStyle/>
+          <a:p>
+            <a:pPr indent="0" marL="0">
+              <a:buNone/>
+            </a:pPr>
+            <a:r>
+              <a:rPr lang="en-US" sz="1050" dirty="0">
+                <a:solidFill>
+                  <a:srgbClr val="52514E"/>
+                </a:solidFill>
+                <a:latin typeface="Calibri" pitchFamily="34" charset="0"/>
+                <a:ea typeface="Calibri" pitchFamily="34" charset="-122"/>
+                <a:cs typeface="Calibri" pitchFamily="34" charset="-120"/>
+              </a:rPr>
+              <a:t>at step-60; ReasonIF 2 / 262 and 0 / 105</a:t>
+            </a:r>
+            <a:endParaRPr lang="en-US" sz="1050" dirty="0"/>
+          </a:p>
+        </p:txBody>
+      </p:sp>
+      <p:sp>
+        <p:nvSpPr>
+          <p:cNvPr id="11" name="Text 8"/>
+          <p:cNvSpPr txBox="1"/>
+          <p:nvPr/>
+        </p:nvSpPr>
+        <p:spPr>
+          <a:xfrm>
+            <a:off x="5760720" y="3337560"/>
+            <a:ext cx="3017520" cy="1280160"/>
+          </a:xfrm>
+          <a:prstGeom prst="rect">
+            <a:avLst/>
+          </a:prstGeom>
+          <a:noFill/>
+          <a:ln/>
+        </p:spPr>
+        <p:txBody>
+          <a:bodyPr wrap="square" lIns="0" tIns="0" rIns="0" bIns="0" rtlCol="0" anchor="t"/>
+          <a:lstStyle/>
+          <a:p>
+            <a:pPr marL="342900" indent="-342900">
+              <a:spcAft>
+                <a:spcPts val="600"/>
+              </a:spcAft>
+              <a:buSzPct val="100000"/>
+              <a:buChar char="•"/>
+            </a:pPr>
+            <a:r>
+              <a:rPr lang="en-US" sz="1100" dirty="0">
+                <a:solidFill>
+                  <a:srgbClr val="0B0B0B"/>
+                </a:solidFill>
+                <a:latin typeface="Calibri" pitchFamily="34" charset="0"/>
+                <a:ea typeface="Calibri" pitchFamily="34" charset="-122"/>
+                <a:cs typeface="Calibri" pitchFamily="34" charset="-120"/>
+              </a:rPr>
+              <a:t>Narration is 5–8 % of the text; the body breaks the same rule in 90–99 % of its own sentences</a:t>
+            </a:r>
+            <a:endParaRPr lang="en-US" sz="1100" dirty="0"/>
+          </a:p>
+          <a:p>
+            <a:pPr marL="342900" indent="-342900">
+              <a:spcAft>
+                <a:spcPts val="600"/>
+              </a:spcAft>
+              <a:buSzPct val="100000"/>
+              <a:buChar char="•"/>
+            </a:pPr>
+            <a:r>
+              <a:rPr lang="en-US" sz="1100" dirty="0">
+                <a:solidFill>
+                  <a:srgbClr val="0B0B0B"/>
+                </a:solidFill>
+                <a:latin typeface="Calibri" pitchFamily="34" charset="0"/>
+                <a:ea typeface="Calibri" pitchFamily="34" charset="-122"/>
+                <a:cs typeface="Calibri" pitchFamily="34" charset="-120"/>
+              </a:rPr>
+              <a:t>Largest continuous gain in any condition: +0.05</a:t>
+            </a:r>
+            <a:endParaRPr lang="en-US" sz="1100" dirty="0"/>
+          </a:p>
+        </p:txBody>
+      </p:sp>
+    </p:spTree>
+  </p:cSld>
+  <p:clrMapOvr>
+    <a:masterClrMapping/>
+  </p:clrMapOvr>
+</p:sld>
+</file>
+
+<file path=ppt/slides/slide14.xml><?xml version="1.0" encoding="utf-8"?>
+<p:sld xmlns:a="http://schemas.openxmlformats.org/drawingml/2006/main" xmlns:r="http://schemas.openxmlformats.org/officeDocument/2006/relationships" xmlns:p="http://schemas.openxmlformats.org/presentationml/2006/main">
+  <p:cSld name="Slide 14">
     <p:bg>
       <p:bgPr>
         <a:solidFill>
@@ -3159,7 +4088,7 @@
                 <a:ea typeface="Calibri" pitchFamily="34" charset="-122"/>
                 <a:cs typeface="Calibri" pitchFamily="34" charset="-120"/>
               </a:rPr>
-              <a:t>It can be reduced: SFT halves the rate, steering halves the density. Prompting does nothing.</a:t>
+              <a:t>It can be reduced, but differently: SFT creates narration-free traces (56 %); steering halves density but leaves narration in nearly every trace. Prompting does nothing.</a:t>
             </a:r>
             <a:endParaRPr lang="en-US" sz="1500" dirty="0"/>
           </a:p>
@@ -3233,9 +4162,9 @@
 </p:sld>
 </file>
 
-<file path=ppt/slides/slide14.xml><?xml version="1.0" encoding="utf-8"?>
+<file path=ppt/slides/slide15.xml><?xml version="1.0" encoding="utf-8"?>
 <p:sld xmlns:a="http://schemas.openxmlformats.org/drawingml/2006/main" xmlns:r="http://schemas.openxmlformats.org/officeDocument/2006/relationships" xmlns:p="http://schemas.openxmlformats.org/presentationml/2006/main">
-  <p:cSld name="Slide 14">
+  <p:cSld name="Slide 15">
     <p:spTree>
       <p:nvGrpSpPr>
         <p:cNvPr id="1" name=""/>

</xml_diff>

<commit_message>
S2: steering at L16/-7 across all nine modes — narration halves (7/9 modes significant), narration-free traces 1->24% (form constraints only), compliance null, ignore_question collapses; summary and deck updated
Co-Authored-By: Claude Fable 5.1 <noreply@anthropic.com>
</commit_message>
<xml_diff>
--- a/META_DISCUSSION_SUMMARY.pptx
+++ b/META_DISCUSSION_SUMMARY.pptx
@@ -119,606 +119,6 @@
     </a:lvl9pPr>
   </p:defaultTextStyle>
 </p:presentation>
-</file>
-
-<file path=ppt/charts/chart1.xml><?xml version="1.0" encoding="utf-8"?>
-<c:chartSpace xmlns:c="http://schemas.openxmlformats.org/drawingml/2006/chart" xmlns:a="http://schemas.openxmlformats.org/drawingml/2006/main" xmlns:r="http://schemas.openxmlformats.org/officeDocument/2006/relationships">
-  <c:date1904 val="0"/>
-  <c:roundedCorners val="1"/>
-  <c:chart>
-    <c:title>
-      <c:tx>
-        <c:rich>
-          <a:bodyPr/>
-          <a:lstStyle/>
-          <a:p>
-            <a:pPr>
-              <a:defRPr sz="1200" b="0" i="0" u="none" strike="noStrike">
-                <a:solidFill>
-                  <a:srgbClr val="0B0B0B"/>
-                </a:solidFill>
-                <a:latin typeface="Calibri"/>
-              </a:defRPr>
-            </a:pPr>
-            <a:r>
-              <a:rPr sz="1200" b="0" i="0" u="none" strike="noStrike">
-                <a:solidFill>
-                  <a:srgbClr val="0B0B0B"/>
-                </a:solidFill>
-                <a:latin typeface="Calibri"/>
-              </a:rPr>
-              <a:t>Traces with no narration at all, %</a:t>
-            </a:r>
-          </a:p>
-        </c:rich>
-      </c:tx>
-      <c:layout/>
-      <c:overlay val="0"/>
-    </c:title>
-    <c:autoTitleDeleted val="0"/>
-    <c:plotArea>
-      <c:layout/>
-      <c:barChart>
-        <c:barDir val="col"/>
-        <c:grouping val="clustered"/>
-        <c:varyColors val="0"/>
-        <c:ser>
-          <c:idx val="0"/>
-          <c:order val="0"/>
-          <c:tx>
-            <c:strRef>
-              <c:f>Sheet1!$B$1</c:f>
-              <c:strCache>
-                <c:ptCount val="1"/>
-                <c:pt idx="0">
-                  <c:v>narration-free</c:v>
-                </c:pt>
-              </c:strCache>
-            </c:strRef>
-          </c:tx>
-          <c:spPr>
-            <a:solidFill>
-              <a:srgbClr val="898781"/>
-            </a:solidFill>
-            <a:effectLst/>
-          </c:spPr>
-          <c:invertIfNegative val="0"/>
-          <c:dLbls>
-            <c:numFmt formatCode="0&quot;%&quot;" sourceLinked="0"/>
-            <c:txPr>
-              <a:bodyPr/>
-              <a:lstStyle/>
-              <a:p>
-                <a:pPr>
-                  <a:defRPr b="0" i="0" strike="noStrike" sz="1100" u="none">
-                    <a:solidFill>
-                      <a:srgbClr val="52514E"/>
-                    </a:solidFill>
-                    <a:latin typeface="Arial"/>
-                  </a:defRPr>
-                </a:pPr>
-              </a:p>
-            </c:txPr>
-            <c:showLegendKey val="0"/>
-            <c:showVal val="1"/>
-            <c:showCatName val="0"/>
-            <c:showSerName val="0"/>
-            <c:showPercent val="0"/>
-            <c:showBubbleSize val="0"/>
-            <c:showLeaderLines val="0"/>
-          </c:dLbls>
-          <c:dPt>
-            <c:idx val="0"/>
-            <c:invertIfNegative val="0"/>
-            <c:bubble3D val="0"/>
-            <c:spPr>
-              <a:solidFill>
-                <a:srgbClr val="898781"/>
-              </a:solidFill>
-              <a:effectLst/>
-            </c:spPr>
-          </c:dPt>
-          <c:dPt>
-            <c:idx val="1"/>
-            <c:invertIfNegative val="0"/>
-            <c:bubble3D val="0"/>
-            <c:spPr>
-              <a:solidFill>
-                <a:srgbClr val="2A78D6"/>
-              </a:solidFill>
-              <a:effectLst/>
-            </c:spPr>
-          </c:dPt>
-          <c:dPt>
-            <c:idx val="2"/>
-            <c:invertIfNegative val="0"/>
-            <c:bubble3D val="0"/>
-            <c:spPr>
-              <a:solidFill>
-                <a:srgbClr val="104281"/>
-              </a:solidFill>
-              <a:effectLst/>
-            </c:spPr>
-          </c:dPt>
-          <c:cat>
-            <c:multiLvlStrRef>
-              <c:f>Sheet1!$A$2:$A$4</c:f>
-              <c:multiLvlStrCache>
-                <c:ptCount val="3"/>
-                <c:lvl>
-                  <c:pt idx="0">
-                    <c:v>unsteered base</c:v>
-                  </c:pt>
-                  <c:pt idx="1">
-                    <c:v>steering, layer 16 −7</c:v>
-                  </c:pt>
-                  <c:pt idx="2">
-                    <c:v>SFT, step-60</c:v>
-                  </c:pt>
-                </c:lvl>
-              </c:multiLvlStrCache>
-            </c:multiLvlStrRef>
-          </c:cat>
-          <c:val>
-            <c:numRef>
-              <c:f>Sheet1!$B$2:$B$4</c:f>
-              <c:numCache>
-                <c:formatCode>General</c:formatCode>
-                <c:ptCount val="3"/>
-                <c:pt idx="0">
-                  <c:v>11</c:v>
-                </c:pt>
-                <c:pt idx="1">
-                  <c:v>17</c:v>
-                </c:pt>
-                <c:pt idx="2">
-                  <c:v>56</c:v>
-                </c:pt>
-              </c:numCache>
-            </c:numRef>
-          </c:val>
-        </c:ser>
-        <c:dLbls>
-          <c:numFmt formatCode="0&quot;%&quot;" sourceLinked="0"/>
-          <c:txPr>
-            <a:bodyPr/>
-            <a:lstStyle/>
-            <a:p>
-              <a:pPr>
-                <a:defRPr b="0" i="0" strike="noStrike" sz="1100" u="none">
-                  <a:solidFill>
-                    <a:srgbClr val="52514E"/>
-                  </a:solidFill>
-                  <a:latin typeface="Arial"/>
-                </a:defRPr>
-              </a:pPr>
-            </a:p>
-          </c:txPr>
-          <c:showLegendKey val="0"/>
-          <c:showVal val="1"/>
-          <c:showCatName val="0"/>
-          <c:showSerName val="0"/>
-          <c:showPercent val="0"/>
-          <c:showBubbleSize val="0"/>
-          <c:showLeaderLines val="0"/>
-        </c:dLbls>
-        <c:gapWidth val="60"/>
-        <c:overlap val="0"/>
-        <c:axId val="2094734554"/>
-        <c:axId val="2094734552"/>
-        <c:axId val="2094734556"/>
-      </c:barChart>
-      <c:catAx>
-        <c:axId val="2094734554"/>
-        <c:scaling>
-          <c:orientation val="minMax"/>
-        </c:scaling>
-        <c:delete val="0"/>
-        <c:axPos val="b"/>
-        <c:numFmt formatCode="General" sourceLinked="1"/>
-        <c:majorTickMark val="out"/>
-        <c:minorTickMark val="none"/>
-        <c:tickLblPos val="low"/>
-        <c:spPr>
-          <a:ln w="12700" cap="flat">
-            <a:noFill/>
-            <a:prstDash val="solid"/>
-            <a:round/>
-          </a:ln>
-        </c:spPr>
-        <c:txPr>
-          <a:bodyPr/>
-          <a:lstStyle/>
-          <a:p>
-            <a:pPr>
-              <a:defRPr sz="1100" b="0" i="0" u="none" strike="noStrike">
-                <a:solidFill>
-                  <a:srgbClr val="52514E"/>
-                </a:solidFill>
-                <a:latin typeface="Arial"/>
-              </a:defRPr>
-            </a:pPr>
-            <a:endParaRPr lang="en-US"/>
-          </a:p>
-        </c:txPr>
-        <c:crossAx val="2094734552"/>
-        <c:crosses val="autoZero"/>
-        <c:auto val="1"/>
-        <c:lblAlgn val="ctr"/>
-        <c:noMultiLvlLbl val="1"/>
-      </c:catAx>
-      <c:valAx>
-        <c:axId val="2094734552"/>
-        <c:scaling>
-          <c:orientation val="minMax"/>
-          <c:max val="70"/>
-          <c:min val="0"/>
-        </c:scaling>
-        <c:delete val="0"/>
-        <c:axPos val="l"/>
-        <c:majorGridlines>
-          <c:spPr>
-            <a:ln w="12700" cap="flat">
-              <a:solidFill>
-                <a:srgbClr val="E1E0D9"/>
-              </a:solidFill>
-              <a:prstDash val="solid"/>
-              <a:round/>
-            </a:ln>
-          </c:spPr>
-        </c:majorGridlines>
-        <c:numFmt formatCode="General" sourceLinked="0"/>
-        <c:majorTickMark val="out"/>
-        <c:minorTickMark val="none"/>
-        <c:tickLblPos val="nextTo"/>
-        <c:spPr>
-          <a:ln w="12700" cap="flat">
-            <a:noFill/>
-            <a:prstDash val="solid"/>
-            <a:round/>
-          </a:ln>
-        </c:spPr>
-        <c:txPr>
-          <a:bodyPr/>
-          <a:lstStyle/>
-          <a:p>
-            <a:pPr>
-              <a:defRPr sz="1000" b="0" i="0" u="none" strike="noStrike">
-                <a:solidFill>
-                  <a:srgbClr val="898781"/>
-                </a:solidFill>
-                <a:latin typeface="Arial"/>
-              </a:defRPr>
-            </a:pPr>
-            <a:endParaRPr lang="en-US"/>
-          </a:p>
-        </c:txPr>
-        <c:crossAx val="2094734554"/>
-        <c:crosses val="autoZero"/>
-        <c:crossBetween val="between"/>
-      </c:valAx>
-      <c:spPr>
-        <a:noFill/>
-        <a:ln>
-          <a:noFill/>
-        </a:ln>
-        <a:effectLst/>
-      </c:spPr>
-    </c:plotArea>
-    <c:plotVisOnly val="1"/>
-    <c:dispBlanksAs val="span"/>
-  </c:chart>
-  <c:spPr>
-    <a:noFill/>
-    <a:ln>
-      <a:noFill/>
-    </a:ln>
-    <a:effectLst/>
-  </c:spPr>
-  <c:externalData r:id="rId1">
-    <c:autoUpdate val="0"/>
-  </c:externalData>
-</c:chartSpace>
-</file>
-
-<file path=ppt/charts/chart2.xml><?xml version="1.0" encoding="utf-8"?>
-<c:chartSpace xmlns:c="http://schemas.openxmlformats.org/drawingml/2006/chart" xmlns:a="http://schemas.openxmlformats.org/drawingml/2006/main" xmlns:r="http://schemas.openxmlformats.org/officeDocument/2006/relationships">
-  <c:date1904 val="0"/>
-  <c:roundedCorners val="1"/>
-  <c:chart>
-    <c:title>
-      <c:tx>
-        <c:rich>
-          <a:bodyPr/>
-          <a:lstStyle/>
-          <a:p>
-            <a:pPr>
-              <a:defRPr sz="1200" b="0" i="0" u="none" strike="noStrike">
-                <a:solidFill>
-                  <a:srgbClr val="0B0B0B"/>
-                </a:solidFill>
-                <a:latin typeface="Calibri"/>
-              </a:defRPr>
-            </a:pPr>
-            <a:r>
-              <a:rPr sz="1200" b="0" i="0" u="none" strike="noStrike">
-                <a:solidFill>
-                  <a:srgbClr val="0B0B0B"/>
-                </a:solidFill>
-                <a:latin typeface="Calibri"/>
-              </a:rPr>
-              <a:t>Narration sentences per 1,000 words</a:t>
-            </a:r>
-          </a:p>
-        </c:rich>
-      </c:tx>
-      <c:layout/>
-      <c:overlay val="0"/>
-    </c:title>
-    <c:autoTitleDeleted val="0"/>
-    <c:plotArea>
-      <c:layout/>
-      <c:barChart>
-        <c:barDir val="col"/>
-        <c:grouping val="clustered"/>
-        <c:varyColors val="0"/>
-        <c:ser>
-          <c:idx val="0"/>
-          <c:order val="0"/>
-          <c:tx>
-            <c:strRef>
-              <c:f>Sheet1!$B$1</c:f>
-              <c:strCache>
-                <c:ptCount val="1"/>
-                <c:pt idx="0">
-                  <c:v>density</c:v>
-                </c:pt>
-              </c:strCache>
-            </c:strRef>
-          </c:tx>
-          <c:spPr>
-            <a:solidFill>
-              <a:srgbClr val="898781"/>
-            </a:solidFill>
-            <a:effectLst/>
-          </c:spPr>
-          <c:invertIfNegative val="0"/>
-          <c:dLbls>
-            <c:numFmt formatCode="0.0" sourceLinked="0"/>
-            <c:txPr>
-              <a:bodyPr/>
-              <a:lstStyle/>
-              <a:p>
-                <a:pPr>
-                  <a:defRPr b="0" i="0" strike="noStrike" sz="1100" u="none">
-                    <a:solidFill>
-                      <a:srgbClr val="52514E"/>
-                    </a:solidFill>
-                    <a:latin typeface="Arial"/>
-                  </a:defRPr>
-                </a:pPr>
-              </a:p>
-            </c:txPr>
-            <c:showLegendKey val="0"/>
-            <c:showVal val="1"/>
-            <c:showCatName val="0"/>
-            <c:showSerName val="0"/>
-            <c:showPercent val="0"/>
-            <c:showBubbleSize val="0"/>
-            <c:showLeaderLines val="0"/>
-          </c:dLbls>
-          <c:dPt>
-            <c:idx val="0"/>
-            <c:invertIfNegative val="0"/>
-            <c:bubble3D val="0"/>
-            <c:spPr>
-              <a:solidFill>
-                <a:srgbClr val="898781"/>
-              </a:solidFill>
-              <a:effectLst/>
-            </c:spPr>
-          </c:dPt>
-          <c:dPt>
-            <c:idx val="1"/>
-            <c:invertIfNegative val="0"/>
-            <c:bubble3D val="0"/>
-            <c:spPr>
-              <a:solidFill>
-                <a:srgbClr val="2A78D6"/>
-              </a:solidFill>
-              <a:effectLst/>
-            </c:spPr>
-          </c:dPt>
-          <c:dPt>
-            <c:idx val="2"/>
-            <c:invertIfNegative val="0"/>
-            <c:bubble3D val="0"/>
-            <c:spPr>
-              <a:solidFill>
-                <a:srgbClr val="104281"/>
-              </a:solidFill>
-              <a:effectLst/>
-            </c:spPr>
-          </c:dPt>
-          <c:cat>
-            <c:multiLvlStrRef>
-              <c:f>Sheet1!$A$2:$A$4</c:f>
-              <c:multiLvlStrCache>
-                <c:ptCount val="3"/>
-                <c:lvl>
-                  <c:pt idx="0">
-                    <c:v>unsteered base</c:v>
-                  </c:pt>
-                  <c:pt idx="1">
-                    <c:v>steering, layer 16 −7</c:v>
-                  </c:pt>
-                  <c:pt idx="2">
-                    <c:v>SFT, step-60</c:v>
-                  </c:pt>
-                </c:lvl>
-              </c:multiLvlStrCache>
-            </c:multiLvlStrRef>
-          </c:cat>
-          <c:val>
-            <c:numRef>
-              <c:f>Sheet1!$B$2:$B$4</c:f>
-              <c:numCache>
-                <c:formatCode>General</c:formatCode>
-                <c:ptCount val="3"/>
-                <c:pt idx="0">
-                  <c:v>6.1</c:v>
-                </c:pt>
-                <c:pt idx="1">
-                  <c:v>3.9</c:v>
-                </c:pt>
-                <c:pt idx="2">
-                  <c:v>1.8</c:v>
-                </c:pt>
-              </c:numCache>
-            </c:numRef>
-          </c:val>
-        </c:ser>
-        <c:dLbls>
-          <c:numFmt formatCode="0.0" sourceLinked="0"/>
-          <c:txPr>
-            <a:bodyPr/>
-            <a:lstStyle/>
-            <a:p>
-              <a:pPr>
-                <a:defRPr b="0" i="0" strike="noStrike" sz="1100" u="none">
-                  <a:solidFill>
-                    <a:srgbClr val="52514E"/>
-                  </a:solidFill>
-                  <a:latin typeface="Arial"/>
-                </a:defRPr>
-              </a:pPr>
-            </a:p>
-          </c:txPr>
-          <c:showLegendKey val="0"/>
-          <c:showVal val="1"/>
-          <c:showCatName val="0"/>
-          <c:showSerName val="0"/>
-          <c:showPercent val="0"/>
-          <c:showBubbleSize val="0"/>
-          <c:showLeaderLines val="0"/>
-        </c:dLbls>
-        <c:gapWidth val="60"/>
-        <c:overlap val="0"/>
-        <c:axId val="2094734554"/>
-        <c:axId val="2094734552"/>
-        <c:axId val="2094734556"/>
-      </c:barChart>
-      <c:catAx>
-        <c:axId val="2094734554"/>
-        <c:scaling>
-          <c:orientation val="minMax"/>
-        </c:scaling>
-        <c:delete val="0"/>
-        <c:axPos val="b"/>
-        <c:numFmt formatCode="General" sourceLinked="1"/>
-        <c:majorTickMark val="out"/>
-        <c:minorTickMark val="none"/>
-        <c:tickLblPos val="low"/>
-        <c:spPr>
-          <a:ln w="12700" cap="flat">
-            <a:noFill/>
-            <a:prstDash val="solid"/>
-            <a:round/>
-          </a:ln>
-        </c:spPr>
-        <c:txPr>
-          <a:bodyPr/>
-          <a:lstStyle/>
-          <a:p>
-            <a:pPr>
-              <a:defRPr sz="1100" b="0" i="0" u="none" strike="noStrike">
-                <a:solidFill>
-                  <a:srgbClr val="52514E"/>
-                </a:solidFill>
-                <a:latin typeface="Arial"/>
-              </a:defRPr>
-            </a:pPr>
-            <a:endParaRPr lang="en-US"/>
-          </a:p>
-        </c:txPr>
-        <c:crossAx val="2094734552"/>
-        <c:crosses val="autoZero"/>
-        <c:auto val="1"/>
-        <c:lblAlgn val="ctr"/>
-        <c:noMultiLvlLbl val="1"/>
-      </c:catAx>
-      <c:valAx>
-        <c:axId val="2094734552"/>
-        <c:scaling>
-          <c:orientation val="minMax"/>
-          <c:max val="8"/>
-          <c:min val="0"/>
-        </c:scaling>
-        <c:delete val="0"/>
-        <c:axPos val="l"/>
-        <c:majorGridlines>
-          <c:spPr>
-            <a:ln w="12700" cap="flat">
-              <a:solidFill>
-                <a:srgbClr val="E1E0D9"/>
-              </a:solidFill>
-              <a:prstDash val="solid"/>
-              <a:round/>
-            </a:ln>
-          </c:spPr>
-        </c:majorGridlines>
-        <c:numFmt formatCode="General" sourceLinked="0"/>
-        <c:majorTickMark val="out"/>
-        <c:minorTickMark val="none"/>
-        <c:tickLblPos val="nextTo"/>
-        <c:spPr>
-          <a:ln w="12700" cap="flat">
-            <a:noFill/>
-            <a:prstDash val="solid"/>
-            <a:round/>
-          </a:ln>
-        </c:spPr>
-        <c:txPr>
-          <a:bodyPr/>
-          <a:lstStyle/>
-          <a:p>
-            <a:pPr>
-              <a:defRPr sz="1000" b="0" i="0" u="none" strike="noStrike">
-                <a:solidFill>
-                  <a:srgbClr val="898781"/>
-                </a:solidFill>
-                <a:latin typeface="Arial"/>
-              </a:defRPr>
-            </a:pPr>
-            <a:endParaRPr lang="en-US"/>
-          </a:p>
-        </c:txPr>
-        <c:crossAx val="2094734554"/>
-        <c:crosses val="autoZero"/>
-        <c:crossBetween val="between"/>
-      </c:valAx>
-      <c:spPr>
-        <a:noFill/>
-        <a:ln>
-          <a:noFill/>
-        </a:ln>
-        <a:effectLst/>
-      </c:spPr>
-    </c:plotArea>
-    <c:plotVisOnly val="1"/>
-    <c:dispBlanksAs val="span"/>
-  </c:chart>
-  <c:spPr>
-    <a:noFill/>
-    <a:ln>
-      <a:noFill/>
-    </a:ln>
-    <a:effectLst/>
-  </c:spPr>
-  <c:externalData r:id="rId1">
-    <c:autoUpdate val="0"/>
-  </c:externalData>
-</c:chartSpace>
 </file>
 
 <file path=ppt/notesMasters/notesMaster1.xml><?xml version="1.0" encoding="utf-8"?>
@@ -2937,7 +2337,7 @@
                 <a:ea typeface="Calibri" pitchFamily="34" charset="-122"/>
                 <a:cs typeface="Calibri" pitchFamily="34" charset="-120"/>
               </a:rPr>
-              <a:t>4.3 · Steering works on narration, not on compliance</a:t>
+              <a:t>4.3 · Steering works on narration in 7 of 9 modes — not on compliance</a:t>
             </a:r>
             <a:endParaRPr lang="en-US" sz="2200" dirty="0"/>
           </a:p>
@@ -2976,7 +2376,7 @@
                 <a:ea typeface="Calibri" pitchFamily="34" charset="-122"/>
                 <a:cs typeface="Calibri" pitchFamily="34" charset="-120"/>
               </a:rPr>
-              <a:t>Layer 16, coefficient −7 · base model, 20 prompts per cell · coefficient × unit direction added at every position</a:t>
+              <a:t>Layer 16, coefficient −7 · all nine CoTControl modes, 30 prompts each · steered minus unsteered on the same prompt</a:t>
             </a:r>
             <a:endParaRPr lang="en-US" sz="1200" dirty="0"/>
           </a:p>
@@ -2984,7 +2384,7 @@
       </p:sp>
       <p:pic>
         <p:nvPicPr>
-          <p:cNvPr id="4" name="Image 0" descr="/home/ola/dev/cot-control-ft/figures/steer_dose_response_base.png">    </p:cNvPr>
+          <p:cNvPr id="4" name="Image 0" descr="/home/ola/dev/cot-control-ft/figures/steer_s2_paired.png">    </p:cNvPr>
           <p:cNvPicPr>
             <a:picLocks noChangeAspect="1"/>
           </p:cNvPicPr>
@@ -2998,7 +2398,7 @@
         <p:spPr>
           <a:xfrm>
             <a:off x="274320" y="1188720"/>
-            <a:ext cx="8595360" cy="3063240"/>
+            <a:ext cx="8595360" cy="2880360"/>
           </a:xfrm>
           <a:prstGeom prst="rect">
             <a:avLst/>
@@ -3013,8 +2413,8 @@
         </p:nvSpPr>
         <p:spPr>
           <a:xfrm>
-            <a:off x="457200" y="4297680"/>
-            <a:ext cx="8229600" cy="640080"/>
+            <a:off x="457200" y="4114800"/>
+            <a:ext cx="8229600" cy="685800"/>
           </a:xfrm>
           <a:prstGeom prst="rect">
             <a:avLst/>
@@ -3034,7 +2434,7 @@
               <a:buChar char="•"/>
             </a:pPr>
             <a:r>
-              <a:rPr lang="en-US" sz="1150" dirty="0">
+              <a:rPr lang="en-US" sz="1050" dirty="0">
                 <a:solidFill>
                   <a:srgbClr val="0B0B0B"/>
                 </a:solidFill>
@@ -3042,9 +2442,9 @@
                 <a:ea typeface="Calibri" pitchFamily="34" charset="-122"/>
                 <a:cs typeface="Calibri" pitchFamily="34" charset="-120"/>
               </a:rPr>
-              <a:t>Narration density halves at −7 (word suppression 6.3 → 3.8 per 1,000 words, lower on 7 of 7 paired prompts); +7 doubles it</a:t>
-            </a:r>
-            <a:endParaRPr lang="en-US" sz="1150" dirty="0"/>
+              <a:t>Narration density 8.3 → 4.2 sentences per 1,000 words, lower on 76 % of 165 paired prompts; termination and accuracy unchanged (76 → 75 %)</a:t>
+            </a:r>
+            <a:endParaRPr lang="en-US" sz="1050" dirty="0"/>
           </a:p>
           <a:p>
             <a:pPr marL="342900" indent="-342900">
@@ -3055,7 +2455,7 @@
               <a:buChar char="•"/>
             </a:pPr>
             <a:r>
-              <a:rPr lang="en-US" sz="1150" dirty="0">
+              <a:rPr lang="en-US" sz="1050" dirty="0">
                 <a:solidFill>
                   <a:srgbClr val="0B0B0B"/>
                 </a:solidFill>
@@ -3063,9 +2463,30 @@
                 <a:ea typeface="Calibri" pitchFamily="34" charset="-122"/>
                 <a:cs typeface="Calibri" pitchFamily="34" charset="-120"/>
               </a:rPr>
-              <a:t>Binary compliance 0 % in every cell; continuous flat or slightly up; accuracy within 10 pp</a:t>
-            </a:r>
-            <a:endParaRPr lang="en-US" sz="1150" dirty="0"/>
+              <a:t>Binary compliance 0 % in every cell, 0 flips; continuous compliance excluding ignore_question −0.007 (80 % CI −0.019 to +0.005): a null</a:t>
+            </a:r>
+            <a:endParaRPr lang="en-US" sz="1050" dirty="0"/>
+          </a:p>
+          <a:p>
+            <a:pPr marL="342900" indent="-342900">
+              <a:spcAft>
+                <a:spcPts val="600"/>
+              </a:spcAft>
+              <a:buSzPct val="100000"/>
+              <a:buChar char="•"/>
+            </a:pPr>
+            <a:r>
+              <a:rPr lang="en-US" sz="1050" dirty="0">
+                <a:solidFill>
+                  <a:srgbClr val="0B0B0B"/>
+                </a:solidFill>
+                <a:latin typeface="Calibri" pitchFamily="34" charset="0"/>
+                <a:ea typeface="Calibri" pitchFamily="34" charset="-122"/>
+                <a:cs typeface="Calibri" pitchFamily="34" charset="-120"/>
+              </a:rPr>
+              <a:t>ignore_question collapses 0.30 → 0.02: there “I must not think about the question” is the compliant content — steering it away leaves only question-discussion</a:t>
+            </a:r>
+            <a:endParaRPr lang="en-US" sz="1050" dirty="0"/>
           </a:p>
         </p:txBody>
       </p:sp>
@@ -3377,7 +2798,7 @@
                 <a:ea typeface="Calibri" pitchFamily="34" charset="-122"/>
                 <a:cs typeface="Calibri" pitchFamily="34" charset="-120"/>
               </a:rPr>
-              <a:t>SFT creates narration-free traces; steering only thins narration</a:t>
+              <a:t>SFT creates narration-free traces everywhere; steering only for constraints about form</a:t>
             </a:r>
             <a:endParaRPr lang="en-US" sz="2200" dirty="0"/>
           </a:p>
@@ -3416,53 +2837,44 @@
                 <a:ea typeface="Calibri" pitchFamily="34" charset="-122"/>
                 <a:cs typeface="Calibri" pitchFamily="34" charset="-120"/>
               </a:rPr>
-              <a:t>Full-trace LLM lister · CoTControl · SFT = step-60 (all modes) · steering = layer 16, −7 (uppercase + word suppression, n 24)</a:t>
+              <a:t>Traces with no narration sentence at all, per mode · unsteered vs steering (layer 16, −7) vs SFT (step-60)</a:t>
             </a:r>
             <a:endParaRPr lang="en-US" sz="1200" dirty="0"/>
           </a:p>
         </p:txBody>
       </p:sp>
-      <p:graphicFrame>
-        <p:nvGraphicFramePr>
-          <p:cNvPr id="4" name="Chart 0" descr=""/>
-          <p:cNvGraphicFramePr/>
-          <p:nvPr/>
-        </p:nvGraphicFramePr>
-        <p:xfrm>
-          <a:off x="457200" y="1280160"/>
-          <a:ext cx="4023360" cy="2834640"/>
-        </p:xfrm>
-        <a:graphic xmlns:a="http://schemas.openxmlformats.org/drawingml/2006/main">
-          <a:graphicData uri="http://schemas.openxmlformats.org/drawingml/2006/chart">
-            <c:chart xmlns:c="http://schemas.openxmlformats.org/drawingml/2006/chart" r:id="rId1"/>
-          </a:graphicData>
-        </a:graphic>
-      </p:graphicFrame>
-      <p:graphicFrame>
-        <p:nvGraphicFramePr>
-          <p:cNvPr id="5" name="Chart 1" descr=""/>
-          <p:cNvGraphicFramePr/>
-          <p:nvPr/>
-        </p:nvGraphicFramePr>
-        <p:xfrm>
-          <a:off x="4663440" y="1280160"/>
-          <a:ext cx="4023360" cy="2834640"/>
-        </p:xfrm>
-        <a:graphic xmlns:a="http://schemas.openxmlformats.org/drawingml/2006/main">
-          <a:graphicData uri="http://schemas.openxmlformats.org/drawingml/2006/chart">
-            <c:chart xmlns:c="http://schemas.openxmlformats.org/drawingml/2006/chart" r:id="rId2"/>
-          </a:graphicData>
-        </a:graphic>
-      </p:graphicFrame>
-      <p:sp>
-        <p:nvSpPr>
-          <p:cNvPr id="6" name="Text 2"/>
-          <p:cNvSpPr txBox="1"/>
-          <p:nvPr/>
-        </p:nvSpPr>
-        <p:spPr>
-          <a:xfrm>
-            <a:off x="457200" y="4206240"/>
+      <p:pic>
+        <p:nvPicPr>
+          <p:cNvPr id="4" name="Image 0" descr="/home/ola/dev/cot-control-ft/figures/steer_s2_narration_free.png">    </p:cNvPr>
+          <p:cNvPicPr>
+            <a:picLocks noChangeAspect="1"/>
+          </p:cNvPicPr>
+          <p:nvPr/>
+        </p:nvPicPr>
+        <p:blipFill>
+          <a:blip r:embed="rId1"/>
+          <a:srcRect l="0" r="0" t="0" b="0"/>
+          <a:stretch/>
+        </p:blipFill>
+        <p:spPr>
+          <a:xfrm>
+            <a:off x="274320" y="1188720"/>
+            <a:ext cx="8595360" cy="3017520"/>
+          </a:xfrm>
+          <a:prstGeom prst="rect">
+            <a:avLst/>
+          </a:prstGeom>
+        </p:spPr>
+      </p:pic>
+      <p:sp>
+        <p:nvSpPr>
+          <p:cNvPr id="5" name="Text 2"/>
+          <p:cNvSpPr txBox="1"/>
+          <p:nvPr/>
+        </p:nvSpPr>
+        <p:spPr>
+          <a:xfrm>
+            <a:off x="457200" y="4251960"/>
             <a:ext cx="8229600" cy="548640"/>
           </a:xfrm>
           <a:prstGeom prst="rect">
@@ -3491,7 +2903,7 @@
                 <a:ea typeface="Calibri" pitchFamily="34" charset="-122"/>
                 <a:cs typeface="Calibri" pitchFamily="34" charset="-120"/>
               </a:rPr>
-              <a:t>Steering lowers the propensity everywhere but leaves narration in nearly every trace (0 of 12 word-suppression traces became narration-free; median still 11 sentences)</a:t>
+              <a:t>Steering: 1 % → 24 % overall — case modes 27–42 %, ignore_question 64 %, end / meow / repeat 8–10 %, word-suppression modes 0–5 %</a:t>
             </a:r>
             <a:endParaRPr lang="en-US" sz="1100" dirty="0"/>
           </a:p>
@@ -3512,48 +2924,9 @@
                 <a:ea typeface="Calibri" pitchFamily="34" charset="-122"/>
                 <a:cs typeface="Calibri" pitchFamily="34" charset="-120"/>
               </a:rPr>
-              <a:t>The coefficient that does remove it (−14) breaks generation. SFT removes it outright from more than half the traces while keeping them intact</a:t>
+              <a:t>SFT: 37–73 % in every mode, 56 % overall (89 % on ReasonIF). Steering lowers the propensity to narrate; SFT switches it off in most traces</a:t>
             </a:r>
             <a:endParaRPr lang="en-US" sz="1100" dirty="0"/>
-          </a:p>
-        </p:txBody>
-      </p:sp>
-      <p:sp>
-        <p:nvSpPr>
-          <p:cNvPr id="7" name="Text 3"/>
-          <p:cNvSpPr txBox="1"/>
-          <p:nvPr/>
-        </p:nvSpPr>
-        <p:spPr>
-          <a:xfrm>
-            <a:off x="457200" y="4709160"/>
-            <a:ext cx="8229600" cy="365760"/>
-          </a:xfrm>
-          <a:prstGeom prst="rect">
-            <a:avLst/>
-          </a:prstGeom>
-          <a:noFill/>
-          <a:ln/>
-        </p:spPr>
-        <p:txBody>
-          <a:bodyPr wrap="square" lIns="0" tIns="0" rIns="0" bIns="0" rtlCol="0" anchor="t"/>
-          <a:lstStyle/>
-          <a:p>
-            <a:pPr indent="0" marL="0">
-              <a:buNone/>
-            </a:pPr>
-            <a:r>
-              <a:rPr lang="en-US" sz="850" dirty="0">
-                <a:solidFill>
-                  <a:srgbClr val="898781"/>
-                </a:solidFill>
-                <a:latin typeface="Calibri" pitchFamily="34" charset="0"/>
-                <a:ea typeface="Calibri" pitchFamily="34" charset="-122"/>
-                <a:cs typeface="Calibri" pitchFamily="34" charset="-120"/>
-              </a:rPr>
-              <a:t>Steering densities use the two-mode subset it was run on (unsteered 5.3 → 3.9 on that subset); the 6.1 baseline is the full base set</a:t>
-            </a:r>
-            <a:endParaRPr lang="en-US" sz="850" dirty="0"/>
           </a:p>
         </p:txBody>
       </p:sp>
@@ -4088,7 +3461,7 @@
                 <a:ea typeface="Calibri" pitchFamily="34" charset="-122"/>
                 <a:cs typeface="Calibri" pitchFamily="34" charset="-120"/>
               </a:rPr>
-              <a:t>It can be reduced, but differently: SFT creates narration-free traces (56 %); steering halves density but leaves narration in nearly every trace. Prompting does nothing.</a:t>
+              <a:t>It can be reduced, but differently: SFT creates narration-free traces in every mode (56 %); steering halves density and frees traces only for constraints about form (24 %). Prompting does nothing.</a:t>
             </a:r>
             <a:endParaRPr lang="en-US" sz="1500" dirty="0"/>
           </a:p>
@@ -4109,7 +3482,7 @@
                 <a:ea typeface="Calibri" pitchFamily="34" charset="-122"/>
                 <a:cs typeface="Calibri" pitchFamily="34" charset="-120"/>
               </a:rPr>
-              <a:t>Reducing it does not raise compliance. Deleting it flips 0 of 2,588 traces; steering it away leaves compliance flat.</a:t>
+              <a:t>Reducing it does not raise compliance: deleting it flips 0 of 2,588 traces; steering it away in nine modes flips 0 of 391 and leaves continuous compliance flat.</a:t>
             </a:r>
             <a:endParaRPr lang="en-US" sz="1500" dirty="0"/>
           </a:p>
@@ -4130,7 +3503,7 @@
                 <a:ea typeface="Calibri" pitchFamily="34" charset="-122"/>
                 <a:cs typeface="Calibri" pitchFamily="34" charset="-120"/>
               </a:rPr>
-              <a:t>Non-compliance is over-determined: narration is one cause among many, and the body violates on its own.</a:t>
+              <a:t>Where narration was the compliant content (ignore_question), removing it removes the compliance: 0.30 → 0.02.</a:t>
             </a:r>
             <a:endParaRPr lang="en-US" sz="1500" dirty="0"/>
           </a:p>
@@ -4148,7 +3521,7 @@
                 <a:ea typeface="Calibri" pitchFamily="34" charset="-122"/>
                 <a:cs typeface="Calibri" pitchFamily="34" charset="-120"/>
               </a:rPr>
-              <a:t>Worth doing for monitorability — a narrating trace is more legible — not as a route to controllability.</a:t>
+              <a:t>Non-compliance is over-determined. Reducing meta-discussion is worth doing for monitorability, not as a route to controllability.</a:t>
             </a:r>
             <a:endParaRPr lang="en-US" sz="1500" dirty="0"/>
           </a:p>
@@ -4299,7 +3672,7 @@
                 <a:ea typeface="Calibri" pitchFamily="34" charset="-122"/>
                 <a:cs typeface="Calibri" pitchFamily="34" charset="-120"/>
               </a:rPr>
-              <a:t>Steering S1: 20 prompts per cell, two conditions; 40–80 % of traces hit the 8,192-token cap, gradeable n 4–16. S2 (nine modes, 30 prompts, cap 10,000) is running</a:t>
+              <a:t>Steering: S2 has 30 prompts per mode, 391 gradeable of 540 (28 % hit the 10,000-token cap); one coefficient (−7) at one layer (16), chosen from the S1 sweep on two modes</a:t>
             </a:r>
             <a:endParaRPr lang="en-US" sz="1200" dirty="0"/>
           </a:p>

</xml_diff>

<commit_message>
deck: fit fixes on the two S2 slides
</commit_message>
<xml_diff>
--- a/META_DISCUSSION_SUMMARY.pptx
+++ b/META_DISCUSSION_SUMMARY.pptx
@@ -2337,7 +2337,7 @@
                 <a:ea typeface="Calibri" pitchFamily="34" charset="-122"/>
                 <a:cs typeface="Calibri" pitchFamily="34" charset="-120"/>
               </a:rPr>
-              <a:t>4.3 · Steering works on narration in 7 of 9 modes — not on compliance</a:t>
+              <a:t>4.3 · Steering: narration down in 7 of 9 modes, compliance flat</a:t>
             </a:r>
             <a:endParaRPr lang="en-US" sz="2200" dirty="0"/>
           </a:p>
@@ -2398,7 +2398,7 @@
         <p:spPr>
           <a:xfrm>
             <a:off x="274320" y="1188720"/>
-            <a:ext cx="8595360" cy="2880360"/>
+            <a:ext cx="8595360" cy="2468880"/>
           </a:xfrm>
           <a:prstGeom prst="rect">
             <a:avLst/>
@@ -2413,8 +2413,8 @@
         </p:nvSpPr>
         <p:spPr>
           <a:xfrm>
-            <a:off x="457200" y="4114800"/>
-            <a:ext cx="8229600" cy="685800"/>
+            <a:off x="457200" y="3703320"/>
+            <a:ext cx="8229600" cy="1051560"/>
           </a:xfrm>
           <a:prstGeom prst="rect">
             <a:avLst/>
@@ -2798,7 +2798,7 @@
                 <a:ea typeface="Calibri" pitchFamily="34" charset="-122"/>
                 <a:cs typeface="Calibri" pitchFamily="34" charset="-120"/>
               </a:rPr>
-              <a:t>SFT creates narration-free traces everywhere; steering only for constraints about form</a:t>
+              <a:t>SFT frees every mode of narration; steering only the form constraints</a:t>
             </a:r>
             <a:endParaRPr lang="en-US" sz="2200" dirty="0"/>
           </a:p>
@@ -2859,7 +2859,7 @@
         <p:spPr>
           <a:xfrm>
             <a:off x="274320" y="1188720"/>
-            <a:ext cx="8595360" cy="3017520"/>
+            <a:ext cx="8595360" cy="2743200"/>
           </a:xfrm>
           <a:prstGeom prst="rect">
             <a:avLst/>
@@ -2874,8 +2874,8 @@
         </p:nvSpPr>
         <p:spPr>
           <a:xfrm>
-            <a:off x="457200" y="4251960"/>
-            <a:ext cx="8229600" cy="548640"/>
+            <a:off x="457200" y="3977640"/>
+            <a:ext cx="8229600" cy="822960"/>
           </a:xfrm>
           <a:prstGeom prst="rect">
             <a:avLst/>

</xml_diff>

<commit_message>
deck: final fit fixes on S2 slides
</commit_message>
<xml_diff>
--- a/META_DISCUSSION_SUMMARY.pptx
+++ b/META_DISCUSSION_SUMMARY.pptx
@@ -2337,7 +2337,7 @@
                 <a:ea typeface="Calibri" pitchFamily="34" charset="-122"/>
                 <a:cs typeface="Calibri" pitchFamily="34" charset="-120"/>
               </a:rPr>
-              <a:t>4.3 · Steering: narration down in 7 of 9 modes, compliance flat</a:t>
+              <a:t>4.3 · Steering: less narration, same compliance</a:t>
             </a:r>
             <a:endParaRPr lang="en-US" sz="2200" dirty="0"/>
           </a:p>
@@ -2398,7 +2398,7 @@
         <p:spPr>
           <a:xfrm>
             <a:off x="274320" y="1188720"/>
-            <a:ext cx="8595360" cy="2468880"/>
+            <a:ext cx="8595360" cy="2377440"/>
           </a:xfrm>
           <a:prstGeom prst="rect">
             <a:avLst/>
@@ -2413,8 +2413,8 @@
         </p:nvSpPr>
         <p:spPr>
           <a:xfrm>
-            <a:off x="457200" y="3703320"/>
-            <a:ext cx="8229600" cy="1051560"/>
+            <a:off x="457200" y="3611880"/>
+            <a:ext cx="8229600" cy="1188720"/>
           </a:xfrm>
           <a:prstGeom prst="rect">
             <a:avLst/>
@@ -2798,7 +2798,7 @@
                 <a:ea typeface="Calibri" pitchFamily="34" charset="-122"/>
                 <a:cs typeface="Calibri" pitchFamily="34" charset="-120"/>
               </a:rPr>
-              <a:t>SFT frees every mode of narration; steering only the form constraints</a:t>
+              <a:t>Narration-free traces: SFT yes, steering only for form</a:t>
             </a:r>
             <a:endParaRPr lang="en-US" sz="2200" dirty="0"/>
           </a:p>

</xml_diff>

<commit_message>
S2b: full dose-response (-14/-7/0/+7) across all nine modes — narration monotone, -14 frees 91% of traces but halves termination and costs 23 pp accuracy, compliance flat at every coefficient; figures, summary, deck
Co-Authored-By: Claude Fable 5.1 <noreply@anthropic.com>
</commit_message>
<xml_diff>
--- a/META_DISCUSSION_SUMMARY.pptx
+++ b/META_DISCUSSION_SUMMARY.pptx
@@ -2550,7 +2550,7 @@
                 <a:ea typeface="Calibri" pitchFamily="34" charset="-122"/>
                 <a:cs typeface="Calibri" pitchFamily="34" charset="-120"/>
               </a:rPr>
-              <a:t>4.3 · A narrow usable band; failures carry the sign</a:t>
+              <a:t>4.3 · Pushing harder removes narration, not non-compliance</a:t>
             </a:r>
             <a:endParaRPr lang="en-US" sz="2200" dirty="0"/>
           </a:p>
@@ -2589,7 +2589,7 @@
                 <a:ea typeface="Calibri" pitchFamily="34" charset="-122"/>
                 <a:cs typeface="Calibri" pitchFamily="34" charset="-120"/>
               </a:rPr>
-              <a:t>Termination by layer and coefficient; paired narration change per prompt</a:t>
+              <a:t>Layer 16, coefficients −14 / −7 / 0 / +7, all nine modes, 270 rollouts per coefficient (pooled)</a:t>
             </a:r>
             <a:endParaRPr lang="en-US" sz="1200" dirty="0"/>
           </a:p>
@@ -2597,7 +2597,7 @@
       </p:sp>
       <p:pic>
         <p:nvPicPr>
-          <p:cNvPr id="4" name="Image 0" descr="/home/ola/dev/cot-control-ft/figures/steer_s1_band_and_paired.png">    </p:cNvPr>
+          <p:cNvPr id="4" name="Image 0" descr="/home/ola/dev/cot-control-ft/figures/steer_dose_all_pooled.png">    </p:cNvPr>
           <p:cNvPicPr>
             <a:picLocks noChangeAspect="1"/>
           </p:cNvPicPr>
@@ -2610,8 +2610,8 @@
         </p:blipFill>
         <p:spPr>
           <a:xfrm>
-            <a:off x="274320" y="1143000"/>
-            <a:ext cx="8595360" cy="2926080"/>
+            <a:off x="274320" y="1188720"/>
+            <a:ext cx="8595360" cy="2148840"/>
           </a:xfrm>
           <a:prstGeom prst="rect">
             <a:avLst/>
@@ -2626,8 +2626,93 @@
         </p:nvSpPr>
         <p:spPr>
           <a:xfrm>
-            <a:off x="457200" y="4114800"/>
-            <a:ext cx="8229600" cy="640080"/>
+            <a:off x="457200" y="3429000"/>
+            <a:ext cx="8229600" cy="1280160"/>
+          </a:xfrm>
+          <a:prstGeom prst="rect">
+            <a:avLst/>
+          </a:prstGeom>
+          <a:noFill/>
+          <a:ln/>
+        </p:spPr>
+        <p:txBody>
+          <a:bodyPr wrap="square" lIns="0" tIns="0" rIns="0" bIns="0" rtlCol="0" anchor="t"/>
+          <a:lstStyle/>
+          <a:p>
+            <a:pPr marL="342900" indent="-342900">
+              <a:spcAft>
+                <a:spcPts val="600"/>
+              </a:spcAft>
+              <a:buSzPct val="100000"/>
+              <a:buChar char="•"/>
+            </a:pPr>
+            <a:r>
+              <a:rPr lang="en-US" sz="1100" dirty="0">
+                <a:solidFill>
+                  <a:srgbClr val="0B0B0B"/>
+                </a:solidFill>
+                <a:latin typeface="Calibri" pitchFamily="34" charset="0"/>
+                <a:ea typeface="Calibri" pitchFamily="34" charset="-122"/>
+                <a:cs typeface="Calibri" pitchFamily="34" charset="-120"/>
+              </a:rPr>
+              <a:t>Narration falls monotonically: 8.3 → 4.2 → 0.2 sentences per 1,000 words; at −14, 91 % of traces are narration-free in every mode — including the word-suppression modes −7 never freed</a:t>
+            </a:r>
+            <a:endParaRPr lang="en-US" sz="1100" dirty="0"/>
+          </a:p>
+          <a:p>
+            <a:pPr marL="342900" indent="-342900">
+              <a:spcAft>
+                <a:spcPts val="600"/>
+              </a:spcAft>
+              <a:buSzPct val="100000"/>
+              <a:buChar char="•"/>
+            </a:pPr>
+            <a:r>
+              <a:rPr lang="en-US" sz="1100" dirty="0">
+                <a:solidFill>
+                  <a:srgbClr val="0B0B0B"/>
+                </a:solidFill>
+                <a:latin typeface="Calibri" pitchFamily="34" charset="0"/>
+                <a:ea typeface="Calibri" pitchFamily="34" charset="-122"/>
+                <a:cs typeface="Calibri" pitchFamily="34" charset="-120"/>
+              </a:rPr>
+              <a:t>But at −14 only 52 % of traces terminate and the survivors lose 23 pp of accuracy on the same prompts (46 % vs 76 %); at +7 only 28 % terminate</a:t>
+            </a:r>
+            <a:endParaRPr lang="en-US" sz="1100" dirty="0"/>
+          </a:p>
+          <a:p>
+            <a:pPr marL="342900" indent="-342900">
+              <a:spcAft>
+                <a:spcPts val="600"/>
+              </a:spcAft>
+              <a:buSzPct val="100000"/>
+              <a:buChar char="•"/>
+            </a:pPr>
+            <a:r>
+              <a:rPr lang="en-US" sz="1100" dirty="0">
+                <a:solidFill>
+                  <a:srgbClr val="0B0B0B"/>
+                </a:solidFill>
+                <a:latin typeface="Calibri" pitchFamily="34" charset="0"/>
+                <a:ea typeface="Calibri" pitchFamily="34" charset="-122"/>
+                <a:cs typeface="Calibri" pitchFamily="34" charset="-120"/>
+              </a:rPr>
+              <a:t>Continuous compliance excluding ignore_question is flat at every coefficient (0.32 / 0.32 / 0.29 / 0.22); binary 0 % in all 36 cells</a:t>
+            </a:r>
+            <a:endParaRPr lang="en-US" sz="1100" dirty="0"/>
+          </a:p>
+        </p:txBody>
+      </p:sp>
+      <p:sp>
+        <p:nvSpPr>
+          <p:cNvPr id="6" name="Text 3"/>
+          <p:cNvSpPr txBox="1"/>
+          <p:nvPr/>
+        </p:nvSpPr>
+        <p:spPr>
+          <a:xfrm>
+            <a:off x="457200" y="4709160"/>
+            <a:ext cx="8229600" cy="365760"/>
           </a:xfrm>
           <a:prstGeom prst="rect">
             <a:avLst/>
@@ -2643,87 +2728,6 @@
               <a:buNone/>
             </a:pPr>
             <a:r>
-              <a:rPr lang="en-US" sz="1100" b="1" dirty="0">
-                <a:solidFill>
-                  <a:srgbClr val="52514E"/>
-                </a:solidFill>
-                <a:latin typeface="Calibri" pitchFamily="34" charset="0"/>
-                <a:ea typeface="Calibri" pitchFamily="34" charset="-122"/>
-                <a:cs typeface="Calibri" pitchFamily="34" charset="-120"/>
-              </a:rPr>
-              <a:t>Pushed away (−14): </a:t>
-            </a:r>
-            <a:pPr indent="0" marL="0">
-              <a:buNone/>
-            </a:pPr>
-            <a:r>
-              <a:rPr lang="en-US" sz="1100" dirty="0">
-                <a:solidFill>
-                  <a:srgbClr val="52514E"/>
-                </a:solidFill>
-                <a:latin typeface="Calibri" pitchFamily="34" charset="0"/>
-                <a:ea typeface="Calibri" pitchFamily="34" charset="-122"/>
-                <a:cs typeface="Calibri" pitchFamily="34" charset="-120"/>
-              </a:rPr>
-              <a:t>“Option D. Wait. Option C. Option D.” × dozens — bare content loops, no constraint-talk.   </a:t>
-            </a:r>
-            <a:pPr indent="0" marL="0">
-              <a:buNone/>
-            </a:pPr>
-            <a:r>
-              <a:rPr lang="en-US" sz="1100" b="1" dirty="0">
-                <a:solidFill>
-                  <a:srgbClr val="52514E"/>
-                </a:solidFill>
-                <a:latin typeface="Calibri" pitchFamily="34" charset="0"/>
-                <a:ea typeface="Calibri" pitchFamily="34" charset="-122"/>
-                <a:cs typeface="Calibri" pitchFamily="34" charset="-120"/>
-              </a:rPr>
-              <a:t>Pushed toward (+7): </a:t>
-            </a:r>
-            <a:pPr indent="0" marL="0">
-              <a:buNone/>
-            </a:pPr>
-            <a:r>
-              <a:rPr lang="en-US" sz="1100" dirty="0">
-                <a:solidFill>
-                  <a:srgbClr val="52514E"/>
-                </a:solidFill>
-                <a:latin typeface="Calibri" pitchFamily="34" charset="0"/>
-                <a:ea typeface="Calibri" pitchFamily="34" charset="-122"/>
-                <a:cs typeface="Calibri" pitchFamily="34" charset="-120"/>
-              </a:rPr>
-              <a:t>“(Wait, I need to make sure I don't use the word 'entangled'). Okay, I'm writing the thought block now.” × 60.</a:t>
-            </a:r>
-            <a:endParaRPr lang="en-US" sz="1100" dirty="0"/>
-          </a:p>
-        </p:txBody>
-      </p:sp>
-      <p:sp>
-        <p:nvSpPr>
-          <p:cNvPr id="6" name="Text 3"/>
-          <p:cNvSpPr txBox="1"/>
-          <p:nvPr/>
-        </p:nvSpPr>
-        <p:spPr>
-          <a:xfrm>
-            <a:off x="457200" y="4709160"/>
-            <a:ext cx="8229600" cy="365760"/>
-          </a:xfrm>
-          <a:prstGeom prst="rect">
-            <a:avLst/>
-          </a:prstGeom>
-          <a:noFill/>
-          <a:ln/>
-        </p:spPr>
-        <p:txBody>
-          <a:bodyPr wrap="square" lIns="0" tIns="0" rIns="0" bIns="0" rtlCol="0" anchor="t"/>
-          <a:lstStyle/>
-          <a:p>
-            <a:pPr indent="0" marL="0">
-              <a:buNone/>
-            </a:pPr>
-            <a:r>
               <a:rPr lang="en-US" sz="850" dirty="0">
                 <a:solidFill>
                   <a:srgbClr val="898781"/>
@@ -2732,7 +2736,7 @@
                 <a:ea typeface="Calibri" pitchFamily="34" charset="-122"/>
                 <a:cs typeface="Calibri" pitchFamily="34" charset="-120"/>
               </a:rPr>
-              <a:t>Layer 12 breaks at every coefficient; layer 20 is robust but inert (narration does not fall there)</a:t>
+              <a:t>Over-steered traces collapse into repetition loops: content fragments when pushed away from narration, constraint-talk when pushed toward it (S1). Per-mode curves: STEERING_RESULTS.md S2b</a:t>
             </a:r>
             <a:endParaRPr lang="en-US" sz="850" dirty="0"/>
           </a:p>
@@ -3461,7 +3465,7 @@
                 <a:ea typeface="Calibri" pitchFamily="34" charset="-122"/>
                 <a:cs typeface="Calibri" pitchFamily="34" charset="-120"/>
               </a:rPr>
-              <a:t>It can be reduced, but differently: SFT creates narration-free traces in every mode (56 %); steering halves density and frees traces only for constraints about form (24 %). Prompting does nothing.</a:t>
+              <a:t>It can be reduced, but differently: SFT creates narration-free traces in every mode (56 %) with intact traces; moderate steering halves density (24 % free); strong steering frees 91 % but halves termination and costs 23 pp of accuracy. Prompting does nothing.</a:t>
             </a:r>
             <a:endParaRPr lang="en-US" sz="1500" dirty="0"/>
           </a:p>
@@ -3672,7 +3676,7 @@
                 <a:ea typeface="Calibri" pitchFamily="34" charset="-122"/>
                 <a:cs typeface="Calibri" pitchFamily="34" charset="-120"/>
               </a:rPr>
-              <a:t>Steering: S2 has 30 prompts per mode, 391 gradeable of 540 (28 % hit the 10,000-token cap); one coefficient (−7) at one layer (16), chosen from the S1 sweep on two modes</a:t>
+              <a:t>Steering: 30 prompts per mode at layer 16, coefficients −14 / −7 / 0 / +7 (1,080 rollouts, 606 gradeable); layer chosen from the S1 sweep on two modes; one steering method (constant vector, all positions)</a:t>
             </a:r>
             <a:endParaRPr lang="en-US" sz="1200" dirty="0"/>
           </a:p>

</xml_diff>